<commit_message>
Polish flight resilience demo and deliverables
</commit_message>
<xml_diff>
--- a/提交包/02_航空网络延误传播与恢复策略_PPT.pptx
+++ b/提交包/02_航空网络延误传播与恢复策略_PPT.pptx
@@ -2,24 +2,24 @@
 <file path=ppt/presentation.xml><?xml version="1.0" encoding="utf-8"?>
 <p:presentation xmlns:p="http://schemas.openxmlformats.org/presentationml/2006/main">
   <p:sldMasterIdLst>
-    <p:sldMasterId xmlns:r="http://schemas.openxmlformats.org/officeDocument/2006/relationships" id="2147483648" r:id="R33db1d2895b94318"/>
+    <p:sldMasterId xmlns:r="http://schemas.openxmlformats.org/officeDocument/2006/relationships" id="2147483648" r:id="R06e6d4ea967648fd"/>
   </p:sldMasterIdLst>
   <p:notesMasterIdLst>
-    <p:notesMasterId xmlns:r="http://schemas.openxmlformats.org/officeDocument/2006/relationships" r:id="R07b2570d0dd74138"/>
+    <p:notesMasterId xmlns:r="http://schemas.openxmlformats.org/officeDocument/2006/relationships" r:id="R7de0df51ce3e44a0"/>
   </p:notesMasterIdLst>
   <p:sldIdLst>
-    <p:sldId xmlns:r="http://schemas.openxmlformats.org/officeDocument/2006/relationships" id="256" r:id="Rbdbd2f89143844e8"/>
-    <p:sldId xmlns:r="http://schemas.openxmlformats.org/officeDocument/2006/relationships" id="257" r:id="R4f08b8753e704030"/>
-    <p:sldId xmlns:r="http://schemas.openxmlformats.org/officeDocument/2006/relationships" id="258" r:id="R0a348c75b54144fa"/>
-    <p:sldId xmlns:r="http://schemas.openxmlformats.org/officeDocument/2006/relationships" id="259" r:id="R72823fbf67f641fb"/>
-    <p:sldId xmlns:r="http://schemas.openxmlformats.org/officeDocument/2006/relationships" id="260" r:id="R164690165bff4781"/>
-    <p:sldId xmlns:r="http://schemas.openxmlformats.org/officeDocument/2006/relationships" id="261" r:id="R7226e67428c841d1"/>
-    <p:sldId xmlns:r="http://schemas.openxmlformats.org/officeDocument/2006/relationships" id="262" r:id="R1cfd2aaf1a254c23"/>
-    <p:sldId xmlns:r="http://schemas.openxmlformats.org/officeDocument/2006/relationships" id="263" r:id="R968e2e45a71d48f4"/>
-    <p:sldId xmlns:r="http://schemas.openxmlformats.org/officeDocument/2006/relationships" id="264" r:id="R552680347ed441f2"/>
-    <p:sldId xmlns:r="http://schemas.openxmlformats.org/officeDocument/2006/relationships" id="265" r:id="R14a08a0dcd6e44ee"/>
-    <p:sldId xmlns:r="http://schemas.openxmlformats.org/officeDocument/2006/relationships" id="266" r:id="R27631a5cdb0342f1"/>
-    <p:sldId xmlns:r="http://schemas.openxmlformats.org/officeDocument/2006/relationships" id="267" r:id="R897ae0cceb34431a"/>
+    <p:sldId xmlns:r="http://schemas.openxmlformats.org/officeDocument/2006/relationships" id="256" r:id="R6b3af8bd7d65404e"/>
+    <p:sldId xmlns:r="http://schemas.openxmlformats.org/officeDocument/2006/relationships" id="257" r:id="Rcb6ba0e7ee3d44e2"/>
+    <p:sldId xmlns:r="http://schemas.openxmlformats.org/officeDocument/2006/relationships" id="258" r:id="R334883c806ac4a31"/>
+    <p:sldId xmlns:r="http://schemas.openxmlformats.org/officeDocument/2006/relationships" id="259" r:id="R27cc4c92d4d84cd9"/>
+    <p:sldId xmlns:r="http://schemas.openxmlformats.org/officeDocument/2006/relationships" id="260" r:id="Re02737b6a64f4068"/>
+    <p:sldId xmlns:r="http://schemas.openxmlformats.org/officeDocument/2006/relationships" id="261" r:id="R7ceec0da20c948cd"/>
+    <p:sldId xmlns:r="http://schemas.openxmlformats.org/officeDocument/2006/relationships" id="262" r:id="R34711327e7224a82"/>
+    <p:sldId xmlns:r="http://schemas.openxmlformats.org/officeDocument/2006/relationships" id="263" r:id="R63dc842d536b4596"/>
+    <p:sldId xmlns:r="http://schemas.openxmlformats.org/officeDocument/2006/relationships" id="264" r:id="R61617d630ddd44a0"/>
+    <p:sldId xmlns:r="http://schemas.openxmlformats.org/officeDocument/2006/relationships" id="265" r:id="R14faa37c6a0f4080"/>
+    <p:sldId xmlns:r="http://schemas.openxmlformats.org/officeDocument/2006/relationships" id="266" r:id="R593da8f602054cb5"/>
+    <p:sldId xmlns:r="http://schemas.openxmlformats.org/officeDocument/2006/relationships" id="267" r:id="R75528177f8ce4771"/>
   </p:sldIdLst>
   <p:sldSz cx="12192000" cy="6858000"/>
   <p:notesSz cx="6858000" cy="9144000"/>
@@ -1292,7 +1292,7 @@
   </p:cSld>
   <p:clrMap bg1="lt1" tx1="dk1" bg2="lt2" tx2="dk2" accent1="accent1" accent2="accent2" accent3="accent3" accent4="accent4" accent5="accent5" accent6="accent6" hlink="hlink" folHlink="folHlink"/>
   <p:sldLayoutIdLst>
-    <p:sldLayoutId xmlns:r="http://schemas.openxmlformats.org/officeDocument/2006/relationships" id="2147483649" r:id="Rae591043d9c443e9"/>
+    <p:sldLayoutId xmlns:r="http://schemas.openxmlformats.org/officeDocument/2006/relationships" id="2147483649" r:id="R43f75d6ed1a74477"/>
   </p:sldLayoutIdLst>
   <p:txStyles>
     <p:titleStyle>
@@ -1790,7 +1790,7 @@
           <p:cNvPr id="1" name="">
             <a:extLst xmlns:a="http://schemas.openxmlformats.org/drawingml/2006/main">
               <a:ext uri="{FF2B5EF4-FFF2-40B4-BE49-F238E27FC236}">
-                <a16:creationId xmlns:a16="http://schemas.microsoft.com/office/drawing/2014/main" id="{30DFD675-BD94-4D70-A01A-4ADF6F62F224}"/>
+                <a16:creationId xmlns:a16="http://schemas.microsoft.com/office/drawing/2014/main" id="{40C25646-9EB5-4347-A00E-7573A0405CFB}"/>
               </a:ext>
             </a:extLst>
           </p:cNvPr>
@@ -1822,7 +1822,7 @@
           <p:cNvPr id="2" name="">
             <a:extLst xmlns:a="http://schemas.openxmlformats.org/drawingml/2006/main">
               <a:ext uri="{FF2B5EF4-FFF2-40B4-BE49-F238E27FC236}">
-                <a16:creationId xmlns:a16="http://schemas.microsoft.com/office/drawing/2014/main" id="{6459B557-0883-4975-8CA8-11DAC909FF8C}"/>
+                <a16:creationId xmlns:a16="http://schemas.microsoft.com/office/drawing/2014/main" id="{F4A24C11-2779-48E6-A536-5B02656BBFA7}"/>
               </a:ext>
             </a:extLst>
           </p:cNvPr>
@@ -1886,7 +1886,7 @@
           <p:cNvPr id="3" name="">
             <a:extLst xmlns:a="http://schemas.openxmlformats.org/drawingml/2006/main">
               <a:ext uri="{FF2B5EF4-FFF2-40B4-BE49-F238E27FC236}">
-                <a16:creationId xmlns:a16="http://schemas.microsoft.com/office/drawing/2014/main" id="{39995970-2A1D-4F15-9CD1-B04DF04EEB0A}"/>
+                <a16:creationId xmlns:a16="http://schemas.microsoft.com/office/drawing/2014/main" id="{5D79592A-E733-4021-95E8-799629A65B9B}"/>
               </a:ext>
             </a:extLst>
           </p:cNvPr>
@@ -1950,7 +1950,7 @@
           <p:cNvPr id="4" name="">
             <a:extLst xmlns:a="http://schemas.openxmlformats.org/drawingml/2006/main">
               <a:ext uri="{FF2B5EF4-FFF2-40B4-BE49-F238E27FC236}">
-                <a16:creationId xmlns:a16="http://schemas.microsoft.com/office/drawing/2014/main" id="{698530C8-BDAE-484D-ABB3-F0C8FFF6A27A}"/>
+                <a16:creationId xmlns:a16="http://schemas.microsoft.com/office/drawing/2014/main" id="{0205BF50-70B4-4FF9-8DD6-F9891F11E724}"/>
               </a:ext>
             </a:extLst>
           </p:cNvPr>
@@ -1986,13 +1986,13 @@
           <p:nvPr/>
         </p:nvPicPr>
         <p:blipFill>
-          <a:blip xmlns:r="http://schemas.openxmlformats.org/officeDocument/2006/relationships" xmlns:a="http://schemas.openxmlformats.org/drawingml/2006/main" r:embed="Rec4099943c954b46"/>
+          <a:blip xmlns:r="http://schemas.openxmlformats.org/officeDocument/2006/relationships" xmlns:a="http://schemas.openxmlformats.org/drawingml/2006/main" r:embed="Rfdf0dcb9b65e4043"/>
           <a:stretch xmlns:a="http://schemas.openxmlformats.org/drawingml/2006/main"/>
         </p:blipFill>
         <p:spPr>
           <a:xfrm xmlns:a="http://schemas.openxmlformats.org/drawingml/2006/main">
-            <a:off x="6191250" y="1405015"/>
-            <a:ext cx="4953000" cy="3686020"/>
+            <a:off x="6191250" y="1402142"/>
+            <a:ext cx="4953000" cy="3691766"/>
           </a:xfrm>
           <a:prstGeom xmlns:a="http://schemas.openxmlformats.org/drawingml/2006/main" prst="rect">
             <a:avLst/>
@@ -2004,7 +2004,7 @@
           <p:cNvPr id="6" name="">
             <a:extLst xmlns:a="http://schemas.openxmlformats.org/drawingml/2006/main">
               <a:ext uri="{FF2B5EF4-FFF2-40B4-BE49-F238E27FC236}">
-                <a16:creationId xmlns:a16="http://schemas.microsoft.com/office/drawing/2014/main" id="{7F99B3C4-8332-497A-9B32-B5112A69A9B4}"/>
+                <a16:creationId xmlns:a16="http://schemas.microsoft.com/office/drawing/2014/main" id="{D1744C8D-E0A7-40FE-A1BB-0EEBA8D69A5A}"/>
               </a:ext>
             </a:extLst>
           </p:cNvPr>
@@ -2068,7 +2068,7 @@
           <p:cNvPr id="7" name="">
             <a:extLst xmlns:a="http://schemas.openxmlformats.org/drawingml/2006/main">
               <a:ext uri="{FF2B5EF4-FFF2-40B4-BE49-F238E27FC236}">
-                <a16:creationId xmlns:a16="http://schemas.microsoft.com/office/drawing/2014/main" id="{13DA9538-6DAC-4950-B837-A27EB788A90C}"/>
+                <a16:creationId xmlns:a16="http://schemas.microsoft.com/office/drawing/2014/main" id="{65227B98-B792-44F6-86E2-3F2BB075036A}"/>
               </a:ext>
             </a:extLst>
           </p:cNvPr>
@@ -2132,7 +2132,7 @@
           <p:cNvPr id="8" name="">
             <a:extLst xmlns:a="http://schemas.openxmlformats.org/drawingml/2006/main">
               <a:ext uri="{FF2B5EF4-FFF2-40B4-BE49-F238E27FC236}">
-                <a16:creationId xmlns:a16="http://schemas.microsoft.com/office/drawing/2014/main" id="{97D73B27-3065-4D8E-BBF4-25A2E0F03110}"/>
+                <a16:creationId xmlns:a16="http://schemas.microsoft.com/office/drawing/2014/main" id="{E8DD78F7-9676-454D-8CBF-1B360A4F2CFF}"/>
               </a:ext>
             </a:extLst>
           </p:cNvPr>
@@ -2164,7 +2164,7 @@
           <p:cNvPr id="9" name="">
             <a:extLst xmlns:a="http://schemas.openxmlformats.org/drawingml/2006/main">
               <a:ext uri="{FF2B5EF4-FFF2-40B4-BE49-F238E27FC236}">
-                <a16:creationId xmlns:a16="http://schemas.microsoft.com/office/drawing/2014/main" id="{5C04C4A5-38A1-49D9-AAB0-BAC9EB1F3BFA}"/>
+                <a16:creationId xmlns:a16="http://schemas.microsoft.com/office/drawing/2014/main" id="{7696FDA2-E99A-4FE6-9451-7C87C274FA00}"/>
               </a:ext>
             </a:extLst>
           </p:cNvPr>
@@ -2228,7 +2228,7 @@
           <p:cNvPr id="10" name="">
             <a:extLst xmlns:a="http://schemas.openxmlformats.org/drawingml/2006/main">
               <a:ext uri="{FF2B5EF4-FFF2-40B4-BE49-F238E27FC236}">
-                <a16:creationId xmlns:a16="http://schemas.microsoft.com/office/drawing/2014/main" id="{88A48720-6DEA-4EFA-9F12-5E04E21ABECE}"/>
+                <a16:creationId xmlns:a16="http://schemas.microsoft.com/office/drawing/2014/main" id="{A2510AB9-E1A8-445A-BAD1-6BDACDF72E17}"/>
               </a:ext>
             </a:extLst>
           </p:cNvPr>
@@ -2292,7 +2292,7 @@
           <p:cNvPr id="11" name="">
             <a:extLst xmlns:a="http://schemas.openxmlformats.org/drawingml/2006/main">
               <a:ext uri="{FF2B5EF4-FFF2-40B4-BE49-F238E27FC236}">
-                <a16:creationId xmlns:a16="http://schemas.microsoft.com/office/drawing/2014/main" id="{9164BAC8-D2B7-4F94-BDE6-EBA679547698}"/>
+                <a16:creationId xmlns:a16="http://schemas.microsoft.com/office/drawing/2014/main" id="{F914A1FB-B346-4239-AF63-60F68FC57681}"/>
               </a:ext>
             </a:extLst>
           </p:cNvPr>
@@ -2354,7 +2354,7 @@
     </p:spTree>
     <p:extLst>
       <p:ext uri="{BB962C8B-B14F-4D97-AF65-F5344CB8AC3E}">
-        <p14:creationId xmlns:p14="http://schemas.microsoft.com/office/powerpoint/2010/main" val="2144815987"/>
+        <p14:creationId xmlns:p14="http://schemas.microsoft.com/office/powerpoint/2010/main" val="1930592145"/>
       </p:ext>
     </p:extLst>
   </p:cSld>
@@ -2378,7 +2378,7 @@
           <p:cNvPr id="1" name="">
             <a:extLst xmlns:a="http://schemas.openxmlformats.org/drawingml/2006/main">
               <a:ext uri="{FF2B5EF4-FFF2-40B4-BE49-F238E27FC236}">
-                <a16:creationId xmlns:a16="http://schemas.microsoft.com/office/drawing/2014/main" id="{848E8C17-2F1E-43E5-A0D6-85E206A098EE}"/>
+                <a16:creationId xmlns:a16="http://schemas.microsoft.com/office/drawing/2014/main" id="{CD5EB68D-2FB2-4379-A137-8C3DA9094B09}"/>
               </a:ext>
             </a:extLst>
           </p:cNvPr>
@@ -2410,7 +2410,7 @@
           <p:cNvPr id="2" name="">
             <a:extLst xmlns:a="http://schemas.openxmlformats.org/drawingml/2006/main">
               <a:ext uri="{FF2B5EF4-FFF2-40B4-BE49-F238E27FC236}">
-                <a16:creationId xmlns:a16="http://schemas.microsoft.com/office/drawing/2014/main" id="{8F81556E-83BA-4F2F-ABC8-1ABFA0869E0E}"/>
+                <a16:creationId xmlns:a16="http://schemas.microsoft.com/office/drawing/2014/main" id="{A81645D5-D7EF-4E91-8A57-B66436DB345D}"/>
               </a:ext>
             </a:extLst>
           </p:cNvPr>
@@ -2474,7 +2474,7 @@
           <p:cNvPr id="3" name="">
             <a:extLst xmlns:a="http://schemas.openxmlformats.org/drawingml/2006/main">
               <a:ext uri="{FF2B5EF4-FFF2-40B4-BE49-F238E27FC236}">
-                <a16:creationId xmlns:a16="http://schemas.microsoft.com/office/drawing/2014/main" id="{E1F32F34-21A4-4268-B855-11A5B757FE74}"/>
+                <a16:creationId xmlns:a16="http://schemas.microsoft.com/office/drawing/2014/main" id="{5E050810-578B-4328-BCC9-395D88AD22E4}"/>
               </a:ext>
             </a:extLst>
           </p:cNvPr>
@@ -2538,7 +2538,7 @@
           <p:cNvPr id="4" name="">
             <a:extLst xmlns:a="http://schemas.openxmlformats.org/drawingml/2006/main">
               <a:ext uri="{FF2B5EF4-FFF2-40B4-BE49-F238E27FC236}">
-                <a16:creationId xmlns:a16="http://schemas.microsoft.com/office/drawing/2014/main" id="{5FBB749D-6ABB-4316-9A1C-78985DD872AC}"/>
+                <a16:creationId xmlns:a16="http://schemas.microsoft.com/office/drawing/2014/main" id="{7390A874-B278-4F07-990F-853A1D33E25A}"/>
               </a:ext>
             </a:extLst>
           </p:cNvPr>
@@ -2574,7 +2574,7 @@
           <p:nvPr/>
         </p:nvPicPr>
         <p:blipFill>
-          <a:blip xmlns:r="http://schemas.openxmlformats.org/officeDocument/2006/relationships" xmlns:a="http://schemas.openxmlformats.org/drawingml/2006/main" r:embed="R1a96ba1a08ae4188"/>
+          <a:blip xmlns:r="http://schemas.openxmlformats.org/officeDocument/2006/relationships" xmlns:a="http://schemas.openxmlformats.org/drawingml/2006/main" r:embed="Rcdc06c075b224893"/>
           <a:stretch xmlns:a="http://schemas.openxmlformats.org/drawingml/2006/main"/>
         </p:blipFill>
         <p:spPr>
@@ -2596,7 +2596,7 @@
           <p:nvPr/>
         </p:nvPicPr>
         <p:blipFill>
-          <a:blip xmlns:r="http://schemas.openxmlformats.org/officeDocument/2006/relationships" xmlns:a="http://schemas.openxmlformats.org/drawingml/2006/main" r:embed="Rdf7f06bce22042f0"/>
+          <a:blip xmlns:r="http://schemas.openxmlformats.org/officeDocument/2006/relationships" xmlns:a="http://schemas.openxmlformats.org/drawingml/2006/main" r:embed="Rc497ef1feb824695"/>
           <a:stretch xmlns:a="http://schemas.openxmlformats.org/drawingml/2006/main"/>
         </p:blipFill>
         <p:spPr>
@@ -2614,7 +2614,7 @@
           <p:cNvPr id="7" name="">
             <a:extLst xmlns:a="http://schemas.openxmlformats.org/drawingml/2006/main">
               <a:ext uri="{FF2B5EF4-FFF2-40B4-BE49-F238E27FC236}">
-                <a16:creationId xmlns:a16="http://schemas.microsoft.com/office/drawing/2014/main" id="{F47DFF6F-AC44-4CEA-8147-91FC4641EAA0}"/>
+                <a16:creationId xmlns:a16="http://schemas.microsoft.com/office/drawing/2014/main" id="{8EE88776-5301-4721-B733-D8603E9DAEBB}"/>
               </a:ext>
             </a:extLst>
           </p:cNvPr>
@@ -2678,7 +2678,7 @@
           <p:cNvPr id="8" name="">
             <a:extLst xmlns:a="http://schemas.openxmlformats.org/drawingml/2006/main">
               <a:ext uri="{FF2B5EF4-FFF2-40B4-BE49-F238E27FC236}">
-                <a16:creationId xmlns:a16="http://schemas.microsoft.com/office/drawing/2014/main" id="{114623DE-B045-4C1C-ADC1-7FB62A52C3B0}"/>
+                <a16:creationId xmlns:a16="http://schemas.microsoft.com/office/drawing/2014/main" id="{A40BDCE0-F650-45DC-9E3A-732B6F543F52}"/>
               </a:ext>
             </a:extLst>
           </p:cNvPr>
@@ -2742,7 +2742,7 @@
           <p:cNvPr id="9" name="">
             <a:extLst xmlns:a="http://schemas.openxmlformats.org/drawingml/2006/main">
               <a:ext uri="{FF2B5EF4-FFF2-40B4-BE49-F238E27FC236}">
-                <a16:creationId xmlns:a16="http://schemas.microsoft.com/office/drawing/2014/main" id="{46DB3620-F44A-4166-A555-3FD21503EE8E}"/>
+                <a16:creationId xmlns:a16="http://schemas.microsoft.com/office/drawing/2014/main" id="{748FB590-52E9-43AE-A820-B1C1759FBFCE}"/>
               </a:ext>
             </a:extLst>
           </p:cNvPr>
@@ -2804,7 +2804,7 @@
     </p:spTree>
     <p:extLst>
       <p:ext uri="{BB962C8B-B14F-4D97-AF65-F5344CB8AC3E}">
-        <p14:creationId xmlns:p14="http://schemas.microsoft.com/office/powerpoint/2010/main" val="1836295512"/>
+        <p14:creationId xmlns:p14="http://schemas.microsoft.com/office/powerpoint/2010/main" val="639942399"/>
       </p:ext>
     </p:extLst>
   </p:cSld>
@@ -2828,7 +2828,7 @@
           <p:cNvPr id="1" name="">
             <a:extLst xmlns:a="http://schemas.openxmlformats.org/drawingml/2006/main">
               <a:ext uri="{FF2B5EF4-FFF2-40B4-BE49-F238E27FC236}">
-                <a16:creationId xmlns:a16="http://schemas.microsoft.com/office/drawing/2014/main" id="{11BDCF87-95AB-47E0-9693-15B3A72A3420}"/>
+                <a16:creationId xmlns:a16="http://schemas.microsoft.com/office/drawing/2014/main" id="{2BEBD4AA-0AB3-40E6-BF5F-47BDF78FED8F}"/>
               </a:ext>
             </a:extLst>
           </p:cNvPr>
@@ -2860,7 +2860,7 @@
           <p:cNvPr id="2" name="">
             <a:extLst xmlns:a="http://schemas.openxmlformats.org/drawingml/2006/main">
               <a:ext uri="{FF2B5EF4-FFF2-40B4-BE49-F238E27FC236}">
-                <a16:creationId xmlns:a16="http://schemas.microsoft.com/office/drawing/2014/main" id="{BFFE4FC6-585D-4016-9AF7-246CB3E0BDD5}"/>
+                <a16:creationId xmlns:a16="http://schemas.microsoft.com/office/drawing/2014/main" id="{690DEB74-B76A-4438-B73C-FA6BD0625E82}"/>
               </a:ext>
             </a:extLst>
           </p:cNvPr>
@@ -2924,7 +2924,7 @@
           <p:cNvPr id="3" name="">
             <a:extLst xmlns:a="http://schemas.openxmlformats.org/drawingml/2006/main">
               <a:ext uri="{FF2B5EF4-FFF2-40B4-BE49-F238E27FC236}">
-                <a16:creationId xmlns:a16="http://schemas.microsoft.com/office/drawing/2014/main" id="{6918374B-3570-43EC-BE7B-DD73ED028611}"/>
+                <a16:creationId xmlns:a16="http://schemas.microsoft.com/office/drawing/2014/main" id="{704920AB-F102-4126-871E-4E5ECC5BC75E}"/>
               </a:ext>
             </a:extLst>
           </p:cNvPr>
@@ -2988,7 +2988,7 @@
           <p:cNvPr id="4" name="">
             <a:extLst xmlns:a="http://schemas.openxmlformats.org/drawingml/2006/main">
               <a:ext uri="{FF2B5EF4-FFF2-40B4-BE49-F238E27FC236}">
-                <a16:creationId xmlns:a16="http://schemas.microsoft.com/office/drawing/2014/main" id="{58FA6850-4F35-44E0-A369-8DA64B1C7C06}"/>
+                <a16:creationId xmlns:a16="http://schemas.microsoft.com/office/drawing/2014/main" id="{78BB00A3-C679-4B22-B938-4CDDFA693D4A}"/>
               </a:ext>
             </a:extLst>
           </p:cNvPr>
@@ -3024,13 +3024,13 @@
           <p:nvPr/>
         </p:nvPicPr>
         <p:blipFill>
-          <a:blip xmlns:r="http://schemas.openxmlformats.org/officeDocument/2006/relationships" xmlns:a="http://schemas.openxmlformats.org/drawingml/2006/main" r:embed="R3d5030b0c7f543ff"/>
+          <a:blip xmlns:r="http://schemas.openxmlformats.org/officeDocument/2006/relationships" xmlns:a="http://schemas.openxmlformats.org/drawingml/2006/main" r:embed="Rf83425b6e7bd4c23"/>
           <a:stretch xmlns:a="http://schemas.openxmlformats.org/drawingml/2006/main"/>
         </p:blipFill>
         <p:spPr>
           <a:xfrm xmlns:a="http://schemas.openxmlformats.org/drawingml/2006/main">
-            <a:off x="666750" y="1575535"/>
-            <a:ext cx="4572000" cy="2754431"/>
+            <a:off x="666750" y="1574948"/>
+            <a:ext cx="4572000" cy="2755605"/>
           </a:xfrm>
           <a:prstGeom xmlns:a="http://schemas.openxmlformats.org/drawingml/2006/main" prst="rect">
             <a:avLst/>
@@ -3046,13 +3046,13 @@
           <p:nvPr/>
         </p:nvPicPr>
         <p:blipFill>
-          <a:blip xmlns:r="http://schemas.openxmlformats.org/officeDocument/2006/relationships" xmlns:a="http://schemas.openxmlformats.org/drawingml/2006/main" r:embed="R1304e87237be45cf"/>
+          <a:blip xmlns:r="http://schemas.openxmlformats.org/officeDocument/2006/relationships" xmlns:a="http://schemas.openxmlformats.org/drawingml/2006/main" r:embed="R2eb85dea39da40d4"/>
           <a:stretch xmlns:a="http://schemas.openxmlformats.org/drawingml/2006/main"/>
         </p:blipFill>
         <p:spPr>
           <a:xfrm xmlns:a="http://schemas.openxmlformats.org/drawingml/2006/main">
-            <a:off x="6191250" y="1613622"/>
-            <a:ext cx="4572000" cy="2678255"/>
+            <a:off x="6191250" y="1612186"/>
+            <a:ext cx="4572000" cy="2681129"/>
           </a:xfrm>
           <a:prstGeom xmlns:a="http://schemas.openxmlformats.org/drawingml/2006/main" prst="rect">
             <a:avLst/>
@@ -3064,7 +3064,7 @@
           <p:cNvPr id="7" name="">
             <a:extLst xmlns:a="http://schemas.openxmlformats.org/drawingml/2006/main">
               <a:ext uri="{FF2B5EF4-FFF2-40B4-BE49-F238E27FC236}">
-                <a16:creationId xmlns:a16="http://schemas.microsoft.com/office/drawing/2014/main" id="{CDB938A1-E5C0-432A-854B-AE12CD69BB68}"/>
+                <a16:creationId xmlns:a16="http://schemas.microsoft.com/office/drawing/2014/main" id="{352D6A4C-6EBA-42CE-8084-07F8806A7884}"/>
               </a:ext>
             </a:extLst>
           </p:cNvPr>
@@ -3128,7 +3128,7 @@
           <p:cNvPr id="8" name="">
             <a:extLst xmlns:a="http://schemas.openxmlformats.org/drawingml/2006/main">
               <a:ext uri="{FF2B5EF4-FFF2-40B4-BE49-F238E27FC236}">
-                <a16:creationId xmlns:a16="http://schemas.microsoft.com/office/drawing/2014/main" id="{834B5EC8-B254-479A-B317-5519EF33CD74}"/>
+                <a16:creationId xmlns:a16="http://schemas.microsoft.com/office/drawing/2014/main" id="{0A1482CC-51B5-4780-B4D8-909E0E005B1C}"/>
               </a:ext>
             </a:extLst>
           </p:cNvPr>
@@ -3192,7 +3192,7 @@
           <p:cNvPr id="9" name="">
             <a:extLst xmlns:a="http://schemas.openxmlformats.org/drawingml/2006/main">
               <a:ext uri="{FF2B5EF4-FFF2-40B4-BE49-F238E27FC236}">
-                <a16:creationId xmlns:a16="http://schemas.microsoft.com/office/drawing/2014/main" id="{D4C39D1E-8303-41EA-9416-8823316C8847}"/>
+                <a16:creationId xmlns:a16="http://schemas.microsoft.com/office/drawing/2014/main" id="{0B271D12-F1F5-40B1-B963-DEE8FFE5D8BF}"/>
               </a:ext>
             </a:extLst>
           </p:cNvPr>
@@ -3254,7 +3254,7 @@
     </p:spTree>
     <p:extLst>
       <p:ext uri="{BB962C8B-B14F-4D97-AF65-F5344CB8AC3E}">
-        <p14:creationId xmlns:p14="http://schemas.microsoft.com/office/powerpoint/2010/main" val="1566127797"/>
+        <p14:creationId xmlns:p14="http://schemas.microsoft.com/office/powerpoint/2010/main" val="109998228"/>
       </p:ext>
     </p:extLst>
   </p:cSld>
@@ -3278,7 +3278,7 @@
           <p:cNvPr id="1" name="">
             <a:extLst xmlns:a="http://schemas.openxmlformats.org/drawingml/2006/main">
               <a:ext uri="{FF2B5EF4-FFF2-40B4-BE49-F238E27FC236}">
-                <a16:creationId xmlns:a16="http://schemas.microsoft.com/office/drawing/2014/main" id="{F7536701-426C-4243-A37F-FE78224FEA12}"/>
+                <a16:creationId xmlns:a16="http://schemas.microsoft.com/office/drawing/2014/main" id="{4F609C4D-BF93-4BCB-AC4D-B77BA1F3A439}"/>
               </a:ext>
             </a:extLst>
           </p:cNvPr>
@@ -3310,7 +3310,7 @@
           <p:cNvPr id="2" name="">
             <a:extLst xmlns:a="http://schemas.openxmlformats.org/drawingml/2006/main">
               <a:ext uri="{FF2B5EF4-FFF2-40B4-BE49-F238E27FC236}">
-                <a16:creationId xmlns:a16="http://schemas.microsoft.com/office/drawing/2014/main" id="{0945F47D-D355-4B0D-A0AC-614B9B0FE375}"/>
+                <a16:creationId xmlns:a16="http://schemas.microsoft.com/office/drawing/2014/main" id="{6D4FED0E-F788-431C-8A2C-FCCCBF9273E6}"/>
               </a:ext>
             </a:extLst>
           </p:cNvPr>
@@ -3374,7 +3374,7 @@
           <p:cNvPr id="3" name="">
             <a:extLst xmlns:a="http://schemas.openxmlformats.org/drawingml/2006/main">
               <a:ext uri="{FF2B5EF4-FFF2-40B4-BE49-F238E27FC236}">
-                <a16:creationId xmlns:a16="http://schemas.microsoft.com/office/drawing/2014/main" id="{EFA8AFA7-D7AB-4EB6-83FE-6FC0352E97CA}"/>
+                <a16:creationId xmlns:a16="http://schemas.microsoft.com/office/drawing/2014/main" id="{7639BA09-00CF-4689-A41A-33A1BF2A828B}"/>
               </a:ext>
             </a:extLst>
           </p:cNvPr>
@@ -3438,7 +3438,7 @@
           <p:cNvPr id="4" name="">
             <a:extLst xmlns:a="http://schemas.openxmlformats.org/drawingml/2006/main">
               <a:ext uri="{FF2B5EF4-FFF2-40B4-BE49-F238E27FC236}">
-                <a16:creationId xmlns:a16="http://schemas.microsoft.com/office/drawing/2014/main" id="{5775BB5A-702D-4A90-B9B8-43B1A7911E90}"/>
+                <a16:creationId xmlns:a16="http://schemas.microsoft.com/office/drawing/2014/main" id="{BCCF60F8-58FD-4065-ACC6-81980774966B}"/>
               </a:ext>
             </a:extLst>
           </p:cNvPr>
@@ -3470,7 +3470,7 @@
           <p:cNvPr id="5" name="">
             <a:extLst xmlns:a="http://schemas.openxmlformats.org/drawingml/2006/main">
               <a:ext uri="{FF2B5EF4-FFF2-40B4-BE49-F238E27FC236}">
-                <a16:creationId xmlns:a16="http://schemas.microsoft.com/office/drawing/2014/main" id="{9A36673D-298B-46C9-B9C3-55ADBEBB02F7}"/>
+                <a16:creationId xmlns:a16="http://schemas.microsoft.com/office/drawing/2014/main" id="{35A50AD3-F63E-4C62-861E-670018E0FA9C}"/>
               </a:ext>
             </a:extLst>
           </p:cNvPr>
@@ -3502,7 +3502,7 @@
           <p:cNvPr id="6" name="">
             <a:extLst xmlns:a="http://schemas.openxmlformats.org/drawingml/2006/main">
               <a:ext uri="{FF2B5EF4-FFF2-40B4-BE49-F238E27FC236}">
-                <a16:creationId xmlns:a16="http://schemas.microsoft.com/office/drawing/2014/main" id="{D1D91887-820B-4BF5-BAD4-6DF1AC6F1A91}"/>
+                <a16:creationId xmlns:a16="http://schemas.microsoft.com/office/drawing/2014/main" id="{94D37A76-9994-4FF5-B1C0-508E328DC5BF}"/>
               </a:ext>
             </a:extLst>
           </p:cNvPr>
@@ -3566,7 +3566,7 @@
           <p:cNvPr id="7" name="">
             <a:extLst xmlns:a="http://schemas.openxmlformats.org/drawingml/2006/main">
               <a:ext uri="{FF2B5EF4-FFF2-40B4-BE49-F238E27FC236}">
-                <a16:creationId xmlns:a16="http://schemas.microsoft.com/office/drawing/2014/main" id="{9C1CA2E1-3C4A-4109-9687-85D5EC6011A4}"/>
+                <a16:creationId xmlns:a16="http://schemas.microsoft.com/office/drawing/2014/main" id="{FF3EF2D0-ABDF-427F-B3D0-E110E508602D}"/>
               </a:ext>
             </a:extLst>
           </p:cNvPr>
@@ -3630,7 +3630,7 @@
           <p:cNvPr id="8" name="">
             <a:extLst xmlns:a="http://schemas.openxmlformats.org/drawingml/2006/main">
               <a:ext uri="{FF2B5EF4-FFF2-40B4-BE49-F238E27FC236}">
-                <a16:creationId xmlns:a16="http://schemas.microsoft.com/office/drawing/2014/main" id="{C2E26993-6FC5-4143-812A-FB8709885225}"/>
+                <a16:creationId xmlns:a16="http://schemas.microsoft.com/office/drawing/2014/main" id="{26AB7811-60C1-4B61-91BB-BCC4088F4AAE}"/>
               </a:ext>
             </a:extLst>
           </p:cNvPr>
@@ -3662,7 +3662,7 @@
           <p:cNvPr id="9" name="">
             <a:extLst xmlns:a="http://schemas.openxmlformats.org/drawingml/2006/main">
               <a:ext uri="{FF2B5EF4-FFF2-40B4-BE49-F238E27FC236}">
-                <a16:creationId xmlns:a16="http://schemas.microsoft.com/office/drawing/2014/main" id="{4D18D8C9-E850-4297-ACF2-AFFBD270E297}"/>
+                <a16:creationId xmlns:a16="http://schemas.microsoft.com/office/drawing/2014/main" id="{355A0A21-1440-444E-9100-50ADB41068F8}"/>
               </a:ext>
             </a:extLst>
           </p:cNvPr>
@@ -3726,7 +3726,7 @@
           <p:cNvPr id="10" name="">
             <a:extLst xmlns:a="http://schemas.openxmlformats.org/drawingml/2006/main">
               <a:ext uri="{FF2B5EF4-FFF2-40B4-BE49-F238E27FC236}">
-                <a16:creationId xmlns:a16="http://schemas.microsoft.com/office/drawing/2014/main" id="{11B3B491-97AF-4D71-A865-F36176234638}"/>
+                <a16:creationId xmlns:a16="http://schemas.microsoft.com/office/drawing/2014/main" id="{71B1ED7F-3164-4D6A-B3CF-76CE4CDACF97}"/>
               </a:ext>
             </a:extLst>
           </p:cNvPr>
@@ -3790,7 +3790,7 @@
           <p:cNvPr id="11" name="">
             <a:extLst xmlns:a="http://schemas.openxmlformats.org/drawingml/2006/main">
               <a:ext uri="{FF2B5EF4-FFF2-40B4-BE49-F238E27FC236}">
-                <a16:creationId xmlns:a16="http://schemas.microsoft.com/office/drawing/2014/main" id="{FF30E9BA-2532-4D7E-8C36-875617C73E3E}"/>
+                <a16:creationId xmlns:a16="http://schemas.microsoft.com/office/drawing/2014/main" id="{52854098-01AB-4F56-AD8E-C94B597C4D71}"/>
               </a:ext>
             </a:extLst>
           </p:cNvPr>
@@ -3822,7 +3822,7 @@
           <p:cNvPr id="12" name="">
             <a:extLst xmlns:a="http://schemas.openxmlformats.org/drawingml/2006/main">
               <a:ext uri="{FF2B5EF4-FFF2-40B4-BE49-F238E27FC236}">
-                <a16:creationId xmlns:a16="http://schemas.microsoft.com/office/drawing/2014/main" id="{DF48FA01-1FF0-4F4B-B67A-1B4BD875CC67}"/>
+                <a16:creationId xmlns:a16="http://schemas.microsoft.com/office/drawing/2014/main" id="{CF8A7898-5AE5-46E7-B3C3-CC9B94ECBA16}"/>
               </a:ext>
             </a:extLst>
           </p:cNvPr>
@@ -3886,7 +3886,7 @@
           <p:cNvPr id="13" name="">
             <a:extLst xmlns:a="http://schemas.openxmlformats.org/drawingml/2006/main">
               <a:ext uri="{FF2B5EF4-FFF2-40B4-BE49-F238E27FC236}">
-                <a16:creationId xmlns:a16="http://schemas.microsoft.com/office/drawing/2014/main" id="{E00A6649-2BB1-474A-986C-5FC076C42B7B}"/>
+                <a16:creationId xmlns:a16="http://schemas.microsoft.com/office/drawing/2014/main" id="{1CA637B4-1F9C-4001-893B-CAE53B6BE485}"/>
               </a:ext>
             </a:extLst>
           </p:cNvPr>
@@ -3950,7 +3950,7 @@
           <p:cNvPr id="14" name="">
             <a:extLst xmlns:a="http://schemas.openxmlformats.org/drawingml/2006/main">
               <a:ext uri="{FF2B5EF4-FFF2-40B4-BE49-F238E27FC236}">
-                <a16:creationId xmlns:a16="http://schemas.microsoft.com/office/drawing/2014/main" id="{CDFC92B7-8693-4E3A-9622-B915B09D8818}"/>
+                <a16:creationId xmlns:a16="http://schemas.microsoft.com/office/drawing/2014/main" id="{3EA20C82-0E75-41A2-B00E-058B1D381443}"/>
               </a:ext>
             </a:extLst>
           </p:cNvPr>
@@ -3982,7 +3982,7 @@
           <p:cNvPr id="15" name="">
             <a:extLst xmlns:a="http://schemas.openxmlformats.org/drawingml/2006/main">
               <a:ext uri="{FF2B5EF4-FFF2-40B4-BE49-F238E27FC236}">
-                <a16:creationId xmlns:a16="http://schemas.microsoft.com/office/drawing/2014/main" id="{09AB9CA0-7E48-4E2A-B97F-E6FDAA6B4276}"/>
+                <a16:creationId xmlns:a16="http://schemas.microsoft.com/office/drawing/2014/main" id="{94100D13-2CBD-47FA-9408-30A64A458951}"/>
               </a:ext>
             </a:extLst>
           </p:cNvPr>
@@ -4046,7 +4046,7 @@
           <p:cNvPr id="16" name="">
             <a:extLst xmlns:a="http://schemas.openxmlformats.org/drawingml/2006/main">
               <a:ext uri="{FF2B5EF4-FFF2-40B4-BE49-F238E27FC236}">
-                <a16:creationId xmlns:a16="http://schemas.microsoft.com/office/drawing/2014/main" id="{5F44844B-67DB-4F6E-A598-9EA2BE670631}"/>
+                <a16:creationId xmlns:a16="http://schemas.microsoft.com/office/drawing/2014/main" id="{838482E3-F331-45F4-9FF0-64A2308A5B8A}"/>
               </a:ext>
             </a:extLst>
           </p:cNvPr>
@@ -4110,7 +4110,7 @@
           <p:cNvPr id="17" name="">
             <a:extLst xmlns:a="http://schemas.openxmlformats.org/drawingml/2006/main">
               <a:ext uri="{FF2B5EF4-FFF2-40B4-BE49-F238E27FC236}">
-                <a16:creationId xmlns:a16="http://schemas.microsoft.com/office/drawing/2014/main" id="{0CE9026C-2C0A-4A27-8603-BB839DC62FAC}"/>
+                <a16:creationId xmlns:a16="http://schemas.microsoft.com/office/drawing/2014/main" id="{CF4D1C52-D7AF-4CED-AD4D-E397B1F30F9D}"/>
               </a:ext>
             </a:extLst>
           </p:cNvPr>
@@ -4142,7 +4142,7 @@
           <p:cNvPr id="18" name="">
             <a:extLst xmlns:a="http://schemas.openxmlformats.org/drawingml/2006/main">
               <a:ext uri="{FF2B5EF4-FFF2-40B4-BE49-F238E27FC236}">
-                <a16:creationId xmlns:a16="http://schemas.microsoft.com/office/drawing/2014/main" id="{AFD8B697-F3D5-4348-8975-9DC7BA46DEEA}"/>
+                <a16:creationId xmlns:a16="http://schemas.microsoft.com/office/drawing/2014/main" id="{94AA546B-2BB3-4054-9922-D49385EC7524}"/>
               </a:ext>
             </a:extLst>
           </p:cNvPr>
@@ -4206,7 +4206,7 @@
           <p:cNvPr id="19" name="">
             <a:extLst xmlns:a="http://schemas.openxmlformats.org/drawingml/2006/main">
               <a:ext uri="{FF2B5EF4-FFF2-40B4-BE49-F238E27FC236}">
-                <a16:creationId xmlns:a16="http://schemas.microsoft.com/office/drawing/2014/main" id="{5960BDA1-FA8F-44A7-AD3A-64DE6A5C299B}"/>
+                <a16:creationId xmlns:a16="http://schemas.microsoft.com/office/drawing/2014/main" id="{817620D7-C689-4D9C-BCB3-DF1082F6538A}"/>
               </a:ext>
             </a:extLst>
           </p:cNvPr>
@@ -4270,7 +4270,7 @@
           <p:cNvPr id="20" name="">
             <a:extLst xmlns:a="http://schemas.openxmlformats.org/drawingml/2006/main">
               <a:ext uri="{FF2B5EF4-FFF2-40B4-BE49-F238E27FC236}">
-                <a16:creationId xmlns:a16="http://schemas.microsoft.com/office/drawing/2014/main" id="{1227EFF7-1533-4675-B5C5-00C5D140B1CD}"/>
+                <a16:creationId xmlns:a16="http://schemas.microsoft.com/office/drawing/2014/main" id="{1524ABEE-B5A0-42E3-BD6C-77156FDA141E}"/>
               </a:ext>
             </a:extLst>
           </p:cNvPr>
@@ -4334,7 +4334,7 @@
           <p:cNvPr id="21" name="">
             <a:extLst xmlns:a="http://schemas.openxmlformats.org/drawingml/2006/main">
               <a:ext uri="{FF2B5EF4-FFF2-40B4-BE49-F238E27FC236}">
-                <a16:creationId xmlns:a16="http://schemas.microsoft.com/office/drawing/2014/main" id="{4BB37081-7F5B-4090-B56A-02B6A03D8FF5}"/>
+                <a16:creationId xmlns:a16="http://schemas.microsoft.com/office/drawing/2014/main" id="{E6B3AEF0-5709-4A8C-9576-E3FDE3FA7A63}"/>
               </a:ext>
             </a:extLst>
           </p:cNvPr>
@@ -4396,7 +4396,7 @@
     </p:spTree>
     <p:extLst>
       <p:ext uri="{BB962C8B-B14F-4D97-AF65-F5344CB8AC3E}">
-        <p14:creationId xmlns:p14="http://schemas.microsoft.com/office/powerpoint/2010/main" val="1342628543"/>
+        <p14:creationId xmlns:p14="http://schemas.microsoft.com/office/powerpoint/2010/main" val="1723912588"/>
       </p:ext>
     </p:extLst>
   </p:cSld>
@@ -4420,7 +4420,7 @@
           <p:cNvPr id="1" name="">
             <a:extLst xmlns:a="http://schemas.openxmlformats.org/drawingml/2006/main">
               <a:ext uri="{FF2B5EF4-FFF2-40B4-BE49-F238E27FC236}">
-                <a16:creationId xmlns:a16="http://schemas.microsoft.com/office/drawing/2014/main" id="{72FB344B-8BDB-4246-8B0D-0944D3518353}"/>
+                <a16:creationId xmlns:a16="http://schemas.microsoft.com/office/drawing/2014/main" id="{D10AAAD2-2B12-4AB9-A71D-28A7D86364E6}"/>
               </a:ext>
             </a:extLst>
           </p:cNvPr>
@@ -4452,7 +4452,7 @@
           <p:cNvPr id="2" name="">
             <a:extLst xmlns:a="http://schemas.openxmlformats.org/drawingml/2006/main">
               <a:ext uri="{FF2B5EF4-FFF2-40B4-BE49-F238E27FC236}">
-                <a16:creationId xmlns:a16="http://schemas.microsoft.com/office/drawing/2014/main" id="{42A72A18-5C1F-4166-B166-0B57D48F925F}"/>
+                <a16:creationId xmlns:a16="http://schemas.microsoft.com/office/drawing/2014/main" id="{559504E2-8A98-4CEB-A8D5-D42204D20054}"/>
               </a:ext>
             </a:extLst>
           </p:cNvPr>
@@ -4516,7 +4516,7 @@
           <p:cNvPr id="3" name="">
             <a:extLst xmlns:a="http://schemas.openxmlformats.org/drawingml/2006/main">
               <a:ext uri="{FF2B5EF4-FFF2-40B4-BE49-F238E27FC236}">
-                <a16:creationId xmlns:a16="http://schemas.microsoft.com/office/drawing/2014/main" id="{C7C6AD48-A455-4B5B-A0C3-3B4C4520CE46}"/>
+                <a16:creationId xmlns:a16="http://schemas.microsoft.com/office/drawing/2014/main" id="{BDFE788B-8995-4C29-B54E-1791CC9A955C}"/>
               </a:ext>
             </a:extLst>
           </p:cNvPr>
@@ -4580,7 +4580,7 @@
           <p:cNvPr id="4" name="">
             <a:extLst xmlns:a="http://schemas.openxmlformats.org/drawingml/2006/main">
               <a:ext uri="{FF2B5EF4-FFF2-40B4-BE49-F238E27FC236}">
-                <a16:creationId xmlns:a16="http://schemas.microsoft.com/office/drawing/2014/main" id="{A3069497-23FD-4D8C-AF9A-CC2AAD6C7331}"/>
+                <a16:creationId xmlns:a16="http://schemas.microsoft.com/office/drawing/2014/main" id="{D6B7A81F-432B-4800-9112-5879BD3A0ACC}"/>
               </a:ext>
             </a:extLst>
           </p:cNvPr>
@@ -4612,7 +4612,7 @@
           <p:cNvPr id="5" name="">
             <a:extLst xmlns:a="http://schemas.openxmlformats.org/drawingml/2006/main">
               <a:ext uri="{FF2B5EF4-FFF2-40B4-BE49-F238E27FC236}">
-                <a16:creationId xmlns:a16="http://schemas.microsoft.com/office/drawing/2014/main" id="{A97CECBD-22D9-48DF-8A27-C33ABBFCC871}"/>
+                <a16:creationId xmlns:a16="http://schemas.microsoft.com/office/drawing/2014/main" id="{A9098080-2AD7-4275-9E87-C3C83483852F}"/>
               </a:ext>
             </a:extLst>
           </p:cNvPr>
@@ -4644,7 +4644,7 @@
           <p:cNvPr id="6" name="">
             <a:extLst xmlns:a="http://schemas.openxmlformats.org/drawingml/2006/main">
               <a:ext uri="{FF2B5EF4-FFF2-40B4-BE49-F238E27FC236}">
-                <a16:creationId xmlns:a16="http://schemas.microsoft.com/office/drawing/2014/main" id="{17937EAA-0254-49B1-81D4-56BD0184A3A1}"/>
+                <a16:creationId xmlns:a16="http://schemas.microsoft.com/office/drawing/2014/main" id="{96827722-411B-4B04-ABAB-22C5B91EBFC1}"/>
               </a:ext>
             </a:extLst>
           </p:cNvPr>
@@ -4676,7 +4676,7 @@
           <p:cNvPr id="7" name="">
             <a:extLst xmlns:a="http://schemas.openxmlformats.org/drawingml/2006/main">
               <a:ext uri="{FF2B5EF4-FFF2-40B4-BE49-F238E27FC236}">
-                <a16:creationId xmlns:a16="http://schemas.microsoft.com/office/drawing/2014/main" id="{54A6DA67-D9B0-4F7C-9130-57CF7C3543B3}"/>
+                <a16:creationId xmlns:a16="http://schemas.microsoft.com/office/drawing/2014/main" id="{D05EF48D-E603-46B8-9595-7114F7D511DA}"/>
               </a:ext>
             </a:extLst>
           </p:cNvPr>
@@ -4740,7 +4740,7 @@
           <p:cNvPr id="8" name="">
             <a:extLst xmlns:a="http://schemas.openxmlformats.org/drawingml/2006/main">
               <a:ext uri="{FF2B5EF4-FFF2-40B4-BE49-F238E27FC236}">
-                <a16:creationId xmlns:a16="http://schemas.microsoft.com/office/drawing/2014/main" id="{47556203-163F-497D-8E4D-1F922FF8C2F1}"/>
+                <a16:creationId xmlns:a16="http://schemas.microsoft.com/office/drawing/2014/main" id="{74A6FD3F-3BAC-4B68-8108-20E7744BB91E}"/>
               </a:ext>
             </a:extLst>
           </p:cNvPr>
@@ -4860,7 +4860,7 @@
           <p:cNvPr id="9" name="">
             <a:extLst xmlns:a="http://schemas.openxmlformats.org/drawingml/2006/main">
               <a:ext uri="{FF2B5EF4-FFF2-40B4-BE49-F238E27FC236}">
-                <a16:creationId xmlns:a16="http://schemas.microsoft.com/office/drawing/2014/main" id="{DD5A1D6E-00B5-4863-98EF-558CBF9DE42F}"/>
+                <a16:creationId xmlns:a16="http://schemas.microsoft.com/office/drawing/2014/main" id="{C892FA2B-83A4-4DEE-A8D9-D12C7AEE9D90}"/>
               </a:ext>
             </a:extLst>
           </p:cNvPr>
@@ -4924,7 +4924,7 @@
           <p:cNvPr id="10" name="">
             <a:extLst xmlns:a="http://schemas.openxmlformats.org/drawingml/2006/main">
               <a:ext uri="{FF2B5EF4-FFF2-40B4-BE49-F238E27FC236}">
-                <a16:creationId xmlns:a16="http://schemas.microsoft.com/office/drawing/2014/main" id="{488FA5C8-F676-4D55-BE21-1E465EC7CA75}"/>
+                <a16:creationId xmlns:a16="http://schemas.microsoft.com/office/drawing/2014/main" id="{BAB8868C-078C-475A-A92A-03104A0C7947}"/>
               </a:ext>
             </a:extLst>
           </p:cNvPr>
@@ -5016,7 +5016,7 @@
           <p:cNvPr id="11" name="">
             <a:extLst xmlns:a="http://schemas.openxmlformats.org/drawingml/2006/main">
               <a:ext uri="{FF2B5EF4-FFF2-40B4-BE49-F238E27FC236}">
-                <a16:creationId xmlns:a16="http://schemas.microsoft.com/office/drawing/2014/main" id="{DA5DC343-104B-4A78-83BB-BC8A07B6933E}"/>
+                <a16:creationId xmlns:a16="http://schemas.microsoft.com/office/drawing/2014/main" id="{5CE6E186-AF37-46C0-80C3-0648BB79CB96}"/>
               </a:ext>
             </a:extLst>
           </p:cNvPr>
@@ -5080,7 +5080,7 @@
           <p:cNvPr id="12" name="">
             <a:extLst xmlns:a="http://schemas.openxmlformats.org/drawingml/2006/main">
               <a:ext uri="{FF2B5EF4-FFF2-40B4-BE49-F238E27FC236}">
-                <a16:creationId xmlns:a16="http://schemas.microsoft.com/office/drawing/2014/main" id="{5F536518-EB39-4097-8D40-23389C5634BC}"/>
+                <a16:creationId xmlns:a16="http://schemas.microsoft.com/office/drawing/2014/main" id="{35397735-6318-468A-9FE1-F7D6EAF8B6E9}"/>
               </a:ext>
             </a:extLst>
           </p:cNvPr>
@@ -5144,7 +5144,7 @@
           <p:cNvPr id="13" name="">
             <a:extLst xmlns:a="http://schemas.openxmlformats.org/drawingml/2006/main">
               <a:ext uri="{FF2B5EF4-FFF2-40B4-BE49-F238E27FC236}">
-                <a16:creationId xmlns:a16="http://schemas.microsoft.com/office/drawing/2014/main" id="{F8D7F29F-1D1E-427E-895B-B1992DA4960C}"/>
+                <a16:creationId xmlns:a16="http://schemas.microsoft.com/office/drawing/2014/main" id="{5B897E13-EA54-46D9-AA88-2FE53953EB60}"/>
               </a:ext>
             </a:extLst>
           </p:cNvPr>
@@ -5206,7 +5206,7 @@
     </p:spTree>
     <p:extLst>
       <p:ext uri="{BB962C8B-B14F-4D97-AF65-F5344CB8AC3E}">
-        <p14:creationId xmlns:p14="http://schemas.microsoft.com/office/powerpoint/2010/main" val="606975987"/>
+        <p14:creationId xmlns:p14="http://schemas.microsoft.com/office/powerpoint/2010/main" val="323155696"/>
       </p:ext>
     </p:extLst>
   </p:cSld>
@@ -5230,7 +5230,7 @@
           <p:cNvPr id="1" name="">
             <a:extLst xmlns:a="http://schemas.openxmlformats.org/drawingml/2006/main">
               <a:ext uri="{FF2B5EF4-FFF2-40B4-BE49-F238E27FC236}">
-                <a16:creationId xmlns:a16="http://schemas.microsoft.com/office/drawing/2014/main" id="{A3F66762-8CE3-4E41-83C0-A3E803AF467B}"/>
+                <a16:creationId xmlns:a16="http://schemas.microsoft.com/office/drawing/2014/main" id="{16017D83-0948-4DEF-8B57-70CDE7A7C339}"/>
               </a:ext>
             </a:extLst>
           </p:cNvPr>
@@ -5262,7 +5262,7 @@
           <p:cNvPr id="2" name="">
             <a:extLst xmlns:a="http://schemas.openxmlformats.org/drawingml/2006/main">
               <a:ext uri="{FF2B5EF4-FFF2-40B4-BE49-F238E27FC236}">
-                <a16:creationId xmlns:a16="http://schemas.microsoft.com/office/drawing/2014/main" id="{499D52A0-891D-4157-8FD4-95EA881A3217}"/>
+                <a16:creationId xmlns:a16="http://schemas.microsoft.com/office/drawing/2014/main" id="{84F31F07-1871-4128-8F9F-7C78A10D70F9}"/>
               </a:ext>
             </a:extLst>
           </p:cNvPr>
@@ -5326,7 +5326,7 @@
           <p:cNvPr id="3" name="">
             <a:extLst xmlns:a="http://schemas.openxmlformats.org/drawingml/2006/main">
               <a:ext uri="{FF2B5EF4-FFF2-40B4-BE49-F238E27FC236}">
-                <a16:creationId xmlns:a16="http://schemas.microsoft.com/office/drawing/2014/main" id="{B302FB4F-8EB8-462F-80DD-212759AF5A58}"/>
+                <a16:creationId xmlns:a16="http://schemas.microsoft.com/office/drawing/2014/main" id="{DE402906-542A-4C66-9D09-707BA6E76FC7}"/>
               </a:ext>
             </a:extLst>
           </p:cNvPr>
@@ -5390,7 +5390,7 @@
           <p:cNvPr id="4" name="">
             <a:extLst xmlns:a="http://schemas.openxmlformats.org/drawingml/2006/main">
               <a:ext uri="{FF2B5EF4-FFF2-40B4-BE49-F238E27FC236}">
-                <a16:creationId xmlns:a16="http://schemas.microsoft.com/office/drawing/2014/main" id="{F9CDDD35-C6EC-461A-A382-CED0AFF555BF}"/>
+                <a16:creationId xmlns:a16="http://schemas.microsoft.com/office/drawing/2014/main" id="{6A6FFA34-1C4B-4F8D-8731-01C7AAA368FF}"/>
               </a:ext>
             </a:extLst>
           </p:cNvPr>
@@ -5422,7 +5422,7 @@
           <p:cNvPr id="5" name="">
             <a:extLst xmlns:a="http://schemas.openxmlformats.org/drawingml/2006/main">
               <a:ext uri="{FF2B5EF4-FFF2-40B4-BE49-F238E27FC236}">
-                <a16:creationId xmlns:a16="http://schemas.microsoft.com/office/drawing/2014/main" id="{DC3F76C2-A23A-43A9-9F97-D4D2FC283D9B}"/>
+                <a16:creationId xmlns:a16="http://schemas.microsoft.com/office/drawing/2014/main" id="{4729CC17-1090-4DC5-BDA5-42C7F0510CF7}"/>
               </a:ext>
             </a:extLst>
           </p:cNvPr>
@@ -5454,7 +5454,7 @@
           <p:cNvPr id="6" name="">
             <a:extLst xmlns:a="http://schemas.openxmlformats.org/drawingml/2006/main">
               <a:ext uri="{FF2B5EF4-FFF2-40B4-BE49-F238E27FC236}">
-                <a16:creationId xmlns:a16="http://schemas.microsoft.com/office/drawing/2014/main" id="{E07ABFE9-2D05-4845-AE47-B65FBE4C7142}"/>
+                <a16:creationId xmlns:a16="http://schemas.microsoft.com/office/drawing/2014/main" id="{D8ABD114-3001-4A59-8738-C80E9F455B76}"/>
               </a:ext>
             </a:extLst>
           </p:cNvPr>
@@ -5518,7 +5518,7 @@
           <p:cNvPr id="7" name="">
             <a:extLst xmlns:a="http://schemas.openxmlformats.org/drawingml/2006/main">
               <a:ext uri="{FF2B5EF4-FFF2-40B4-BE49-F238E27FC236}">
-                <a16:creationId xmlns:a16="http://schemas.microsoft.com/office/drawing/2014/main" id="{23FD4DB8-6443-4C2C-88DF-534BC274687E}"/>
+                <a16:creationId xmlns:a16="http://schemas.microsoft.com/office/drawing/2014/main" id="{09240C6C-6056-4F2F-8CDB-3FBED6A045AF}"/>
               </a:ext>
             </a:extLst>
           </p:cNvPr>
@@ -5651,7 +5651,7 @@
           <p:cNvPr id="8" name="">
             <a:extLst xmlns:a="http://schemas.openxmlformats.org/drawingml/2006/main">
               <a:ext uri="{FF2B5EF4-FFF2-40B4-BE49-F238E27FC236}">
-                <a16:creationId xmlns:a16="http://schemas.microsoft.com/office/drawing/2014/main" id="{E36229B3-BE3C-46A6-8CAA-BA135890C04A}"/>
+                <a16:creationId xmlns:a16="http://schemas.microsoft.com/office/drawing/2014/main" id="{637C3934-6EEE-46D8-ADA6-A28C97BFEC36}"/>
               </a:ext>
             </a:extLst>
           </p:cNvPr>
@@ -5683,7 +5683,7 @@
           <p:cNvPr id="9" name="">
             <a:extLst xmlns:a="http://schemas.openxmlformats.org/drawingml/2006/main">
               <a:ext uri="{FF2B5EF4-FFF2-40B4-BE49-F238E27FC236}">
-                <a16:creationId xmlns:a16="http://schemas.microsoft.com/office/drawing/2014/main" id="{96D851BE-7990-4F40-A978-F2E1A0F68BC7}"/>
+                <a16:creationId xmlns:a16="http://schemas.microsoft.com/office/drawing/2014/main" id="{E6C2D55B-E62F-4130-8AA7-5E7723725222}"/>
               </a:ext>
             </a:extLst>
           </p:cNvPr>
@@ -5747,7 +5747,7 @@
           <p:cNvPr id="10" name="">
             <a:extLst xmlns:a="http://schemas.openxmlformats.org/drawingml/2006/main">
               <a:ext uri="{FF2B5EF4-FFF2-40B4-BE49-F238E27FC236}">
-                <a16:creationId xmlns:a16="http://schemas.microsoft.com/office/drawing/2014/main" id="{E44E2EAB-65BF-4E29-A5FE-94B0B0A20E37}"/>
+                <a16:creationId xmlns:a16="http://schemas.microsoft.com/office/drawing/2014/main" id="{A686B101-E1DA-44C4-8615-5A669C847719}"/>
               </a:ext>
             </a:extLst>
           </p:cNvPr>
@@ -5811,7 +5811,7 @@
           <p:cNvPr id="11" name="">
             <a:extLst xmlns:a="http://schemas.openxmlformats.org/drawingml/2006/main">
               <a:ext uri="{FF2B5EF4-FFF2-40B4-BE49-F238E27FC236}">
-                <a16:creationId xmlns:a16="http://schemas.microsoft.com/office/drawing/2014/main" id="{2FEFC435-E5A5-45B8-BAD7-85A4692D91CF}"/>
+                <a16:creationId xmlns:a16="http://schemas.microsoft.com/office/drawing/2014/main" id="{489B7693-037B-42FC-B3BF-296FB71EC428}"/>
               </a:ext>
             </a:extLst>
           </p:cNvPr>
@@ -5843,7 +5843,7 @@
           <p:cNvPr id="12" name="">
             <a:extLst xmlns:a="http://schemas.openxmlformats.org/drawingml/2006/main">
               <a:ext uri="{FF2B5EF4-FFF2-40B4-BE49-F238E27FC236}">
-                <a16:creationId xmlns:a16="http://schemas.microsoft.com/office/drawing/2014/main" id="{188FF052-ABCC-4138-96E8-1192070CBF88}"/>
+                <a16:creationId xmlns:a16="http://schemas.microsoft.com/office/drawing/2014/main" id="{1CCC9CA7-48E4-4F53-94EE-A4FEF51DA6D7}"/>
               </a:ext>
             </a:extLst>
           </p:cNvPr>
@@ -5907,7 +5907,7 @@
           <p:cNvPr id="13" name="">
             <a:extLst xmlns:a="http://schemas.openxmlformats.org/drawingml/2006/main">
               <a:ext uri="{FF2B5EF4-FFF2-40B4-BE49-F238E27FC236}">
-                <a16:creationId xmlns:a16="http://schemas.microsoft.com/office/drawing/2014/main" id="{23161C20-D801-4EDB-9465-966A8B466EAD}"/>
+                <a16:creationId xmlns:a16="http://schemas.microsoft.com/office/drawing/2014/main" id="{F4F84A69-DE37-48CB-A0D2-9BBF93F68FEB}"/>
               </a:ext>
             </a:extLst>
           </p:cNvPr>
@@ -6040,7 +6040,7 @@
           <p:cNvPr id="14" name="">
             <a:extLst xmlns:a="http://schemas.openxmlformats.org/drawingml/2006/main">
               <a:ext uri="{FF2B5EF4-FFF2-40B4-BE49-F238E27FC236}">
-                <a16:creationId xmlns:a16="http://schemas.microsoft.com/office/drawing/2014/main" id="{D6A2A0B7-EA9B-4060-BB80-40B24F0314B0}"/>
+                <a16:creationId xmlns:a16="http://schemas.microsoft.com/office/drawing/2014/main" id="{03C77744-4640-4B1D-87FD-F7299B3EE433}"/>
               </a:ext>
             </a:extLst>
           </p:cNvPr>
@@ -6072,7 +6072,7 @@
           <p:cNvPr id="15" name="">
             <a:extLst xmlns:a="http://schemas.openxmlformats.org/drawingml/2006/main">
               <a:ext uri="{FF2B5EF4-FFF2-40B4-BE49-F238E27FC236}">
-                <a16:creationId xmlns:a16="http://schemas.microsoft.com/office/drawing/2014/main" id="{61A70F60-AC06-44D2-BE4B-54A402A8B5C9}"/>
+                <a16:creationId xmlns:a16="http://schemas.microsoft.com/office/drawing/2014/main" id="{826983C7-FACE-495A-8C6D-EB968FAC0A94}"/>
               </a:ext>
             </a:extLst>
           </p:cNvPr>
@@ -6136,7 +6136,7 @@
           <p:cNvPr id="16" name="">
             <a:extLst xmlns:a="http://schemas.openxmlformats.org/drawingml/2006/main">
               <a:ext uri="{FF2B5EF4-FFF2-40B4-BE49-F238E27FC236}">
-                <a16:creationId xmlns:a16="http://schemas.microsoft.com/office/drawing/2014/main" id="{4619974E-C784-433E-A9F5-BD9DC857749B}"/>
+                <a16:creationId xmlns:a16="http://schemas.microsoft.com/office/drawing/2014/main" id="{E94020A2-D76E-45B8-A46D-1FCE9F603741}"/>
               </a:ext>
             </a:extLst>
           </p:cNvPr>
@@ -6200,7 +6200,7 @@
           <p:cNvPr id="17" name="">
             <a:extLst xmlns:a="http://schemas.openxmlformats.org/drawingml/2006/main">
               <a:ext uri="{FF2B5EF4-FFF2-40B4-BE49-F238E27FC236}">
-                <a16:creationId xmlns:a16="http://schemas.microsoft.com/office/drawing/2014/main" id="{FEA097B3-4AD4-49C9-89FF-E44EEA65E38A}"/>
+                <a16:creationId xmlns:a16="http://schemas.microsoft.com/office/drawing/2014/main" id="{2CE281A8-F7FF-4279-8D27-A7B4FAB0B707}"/>
               </a:ext>
             </a:extLst>
           </p:cNvPr>
@@ -6232,7 +6232,7 @@
           <p:cNvPr id="18" name="">
             <a:extLst xmlns:a="http://schemas.openxmlformats.org/drawingml/2006/main">
               <a:ext uri="{FF2B5EF4-FFF2-40B4-BE49-F238E27FC236}">
-                <a16:creationId xmlns:a16="http://schemas.microsoft.com/office/drawing/2014/main" id="{EA852900-AEC3-4D31-A073-0EF80FB5276F}"/>
+                <a16:creationId xmlns:a16="http://schemas.microsoft.com/office/drawing/2014/main" id="{A30B7AD9-BC74-4DDA-9B89-A16C26D57D75}"/>
               </a:ext>
             </a:extLst>
           </p:cNvPr>
@@ -6296,7 +6296,7 @@
           <p:cNvPr id="19" name="">
             <a:extLst xmlns:a="http://schemas.openxmlformats.org/drawingml/2006/main">
               <a:ext uri="{FF2B5EF4-FFF2-40B4-BE49-F238E27FC236}">
-                <a16:creationId xmlns:a16="http://schemas.microsoft.com/office/drawing/2014/main" id="{D2C684AB-285D-470D-9939-1D41E86417F6}"/>
+                <a16:creationId xmlns:a16="http://schemas.microsoft.com/office/drawing/2014/main" id="{50F9C185-B395-4759-B310-268912310791}"/>
               </a:ext>
             </a:extLst>
           </p:cNvPr>
@@ -6360,7 +6360,7 @@
           <p:cNvPr id="20" name="">
             <a:extLst xmlns:a="http://schemas.openxmlformats.org/drawingml/2006/main">
               <a:ext uri="{FF2B5EF4-FFF2-40B4-BE49-F238E27FC236}">
-                <a16:creationId xmlns:a16="http://schemas.microsoft.com/office/drawing/2014/main" id="{0008CCE2-B491-459F-BB63-68FB45A0E78C}"/>
+                <a16:creationId xmlns:a16="http://schemas.microsoft.com/office/drawing/2014/main" id="{E8473764-8E3D-41DE-B1E5-6B5706ABEB0F}"/>
               </a:ext>
             </a:extLst>
           </p:cNvPr>
@@ -6392,7 +6392,7 @@
           <p:cNvPr id="21" name="">
             <a:extLst xmlns:a="http://schemas.openxmlformats.org/drawingml/2006/main">
               <a:ext uri="{FF2B5EF4-FFF2-40B4-BE49-F238E27FC236}">
-                <a16:creationId xmlns:a16="http://schemas.microsoft.com/office/drawing/2014/main" id="{43028AE7-7048-43A9-9AD6-04B091BF25FF}"/>
+                <a16:creationId xmlns:a16="http://schemas.microsoft.com/office/drawing/2014/main" id="{928BF5C1-2666-4187-9659-9A78811625B5}"/>
               </a:ext>
             </a:extLst>
           </p:cNvPr>
@@ -6456,7 +6456,7 @@
           <p:cNvPr id="22" name="">
             <a:extLst xmlns:a="http://schemas.openxmlformats.org/drawingml/2006/main">
               <a:ext uri="{FF2B5EF4-FFF2-40B4-BE49-F238E27FC236}">
-                <a16:creationId xmlns:a16="http://schemas.microsoft.com/office/drawing/2014/main" id="{6A9F9447-5112-4E58-A1E5-E02F789F19AD}"/>
+                <a16:creationId xmlns:a16="http://schemas.microsoft.com/office/drawing/2014/main" id="{A66C28E6-2786-4BED-A364-4D8E36821D61}"/>
               </a:ext>
             </a:extLst>
           </p:cNvPr>
@@ -6520,7 +6520,7 @@
           <p:cNvPr id="23" name="">
             <a:extLst xmlns:a="http://schemas.openxmlformats.org/drawingml/2006/main">
               <a:ext uri="{FF2B5EF4-FFF2-40B4-BE49-F238E27FC236}">
-                <a16:creationId xmlns:a16="http://schemas.microsoft.com/office/drawing/2014/main" id="{CEC49CE4-E9C0-460B-951B-79DB658FAE0C}"/>
+                <a16:creationId xmlns:a16="http://schemas.microsoft.com/office/drawing/2014/main" id="{67B76E29-8B66-4321-B0F9-3187CC45B1DE}"/>
               </a:ext>
             </a:extLst>
           </p:cNvPr>
@@ -6552,7 +6552,7 @@
           <p:cNvPr id="24" name="">
             <a:extLst xmlns:a="http://schemas.openxmlformats.org/drawingml/2006/main">
               <a:ext uri="{FF2B5EF4-FFF2-40B4-BE49-F238E27FC236}">
-                <a16:creationId xmlns:a16="http://schemas.microsoft.com/office/drawing/2014/main" id="{9232B2F3-FD98-4997-ABA3-07CD4D38EBB1}"/>
+                <a16:creationId xmlns:a16="http://schemas.microsoft.com/office/drawing/2014/main" id="{32419DEB-C1FC-4A33-A965-6B51E44EE397}"/>
               </a:ext>
             </a:extLst>
           </p:cNvPr>
@@ -6616,7 +6616,7 @@
           <p:cNvPr id="25" name="">
             <a:extLst xmlns:a="http://schemas.openxmlformats.org/drawingml/2006/main">
               <a:ext uri="{FF2B5EF4-FFF2-40B4-BE49-F238E27FC236}">
-                <a16:creationId xmlns:a16="http://schemas.microsoft.com/office/drawing/2014/main" id="{E0BC2861-1ADD-4097-93C6-16F3E7D277B4}"/>
+                <a16:creationId xmlns:a16="http://schemas.microsoft.com/office/drawing/2014/main" id="{9E3BF7F5-6442-4335-A0D2-0B7366F72A0A}"/>
               </a:ext>
             </a:extLst>
           </p:cNvPr>
@@ -6680,7 +6680,7 @@
           <p:cNvPr id="26" name="">
             <a:extLst xmlns:a="http://schemas.openxmlformats.org/drawingml/2006/main">
               <a:ext uri="{FF2B5EF4-FFF2-40B4-BE49-F238E27FC236}">
-                <a16:creationId xmlns:a16="http://schemas.microsoft.com/office/drawing/2014/main" id="{074047BF-39A9-4C5C-B6D9-6C678955ED60}"/>
+                <a16:creationId xmlns:a16="http://schemas.microsoft.com/office/drawing/2014/main" id="{4BB5D330-71DB-4BBD-96AB-EE0736EFF6D1}"/>
               </a:ext>
             </a:extLst>
           </p:cNvPr>
@@ -6712,7 +6712,7 @@
           <p:cNvPr id="27" name="">
             <a:extLst xmlns:a="http://schemas.openxmlformats.org/drawingml/2006/main">
               <a:ext uri="{FF2B5EF4-FFF2-40B4-BE49-F238E27FC236}">
-                <a16:creationId xmlns:a16="http://schemas.microsoft.com/office/drawing/2014/main" id="{B57977F4-1B84-4D3C-968F-1F30D9AF1ABA}"/>
+                <a16:creationId xmlns:a16="http://schemas.microsoft.com/office/drawing/2014/main" id="{70BCD8D1-91FF-45F9-A60E-A8F61EB9892D}"/>
               </a:ext>
             </a:extLst>
           </p:cNvPr>
@@ -6776,7 +6776,7 @@
           <p:cNvPr id="28" name="">
             <a:extLst xmlns:a="http://schemas.openxmlformats.org/drawingml/2006/main">
               <a:ext uri="{FF2B5EF4-FFF2-40B4-BE49-F238E27FC236}">
-                <a16:creationId xmlns:a16="http://schemas.microsoft.com/office/drawing/2014/main" id="{B151C967-4D83-402E-BD2D-4EF124994EEA}"/>
+                <a16:creationId xmlns:a16="http://schemas.microsoft.com/office/drawing/2014/main" id="{9D4A30C6-F650-4A3B-875A-11F2B01669AF}"/>
               </a:ext>
             </a:extLst>
           </p:cNvPr>
@@ -6840,7 +6840,7 @@
           <p:cNvPr id="29" name="">
             <a:extLst xmlns:a="http://schemas.openxmlformats.org/drawingml/2006/main">
               <a:ext uri="{FF2B5EF4-FFF2-40B4-BE49-F238E27FC236}">
-                <a16:creationId xmlns:a16="http://schemas.microsoft.com/office/drawing/2014/main" id="{A148F28B-D81D-4937-9D1B-6B8B8E03479C}"/>
+                <a16:creationId xmlns:a16="http://schemas.microsoft.com/office/drawing/2014/main" id="{229D4BDB-1B1A-4220-A021-EB2BA209909C}"/>
               </a:ext>
             </a:extLst>
           </p:cNvPr>
@@ -6872,7 +6872,7 @@
           <p:cNvPr id="30" name="">
             <a:extLst xmlns:a="http://schemas.openxmlformats.org/drawingml/2006/main">
               <a:ext uri="{FF2B5EF4-FFF2-40B4-BE49-F238E27FC236}">
-                <a16:creationId xmlns:a16="http://schemas.microsoft.com/office/drawing/2014/main" id="{9B7D0092-565B-4466-A5A5-A7D9936D1FAB}"/>
+                <a16:creationId xmlns:a16="http://schemas.microsoft.com/office/drawing/2014/main" id="{E943658B-11A0-497D-AE42-FEE1A6FCA369}"/>
               </a:ext>
             </a:extLst>
           </p:cNvPr>
@@ -6936,7 +6936,7 @@
           <p:cNvPr id="31" name="">
             <a:extLst xmlns:a="http://schemas.openxmlformats.org/drawingml/2006/main">
               <a:ext uri="{FF2B5EF4-FFF2-40B4-BE49-F238E27FC236}">
-                <a16:creationId xmlns:a16="http://schemas.microsoft.com/office/drawing/2014/main" id="{36E8792E-BBF6-4F2F-8D4F-46C7A46DB67C}"/>
+                <a16:creationId xmlns:a16="http://schemas.microsoft.com/office/drawing/2014/main" id="{C730F72E-10AD-4751-85A8-12EBF893AE88}"/>
               </a:ext>
             </a:extLst>
           </p:cNvPr>
@@ -7000,7 +7000,7 @@
           <p:cNvPr id="32" name="">
             <a:extLst xmlns:a="http://schemas.openxmlformats.org/drawingml/2006/main">
               <a:ext uri="{FF2B5EF4-FFF2-40B4-BE49-F238E27FC236}">
-                <a16:creationId xmlns:a16="http://schemas.microsoft.com/office/drawing/2014/main" id="{5A4F6BE9-3FDB-4EB9-BE6D-801E2409B890}"/>
+                <a16:creationId xmlns:a16="http://schemas.microsoft.com/office/drawing/2014/main" id="{29FC0229-C78B-47B1-A28A-B9336EEB96CF}"/>
               </a:ext>
             </a:extLst>
           </p:cNvPr>
@@ -7064,7 +7064,7 @@
           <p:cNvPr id="33" name="">
             <a:extLst xmlns:a="http://schemas.openxmlformats.org/drawingml/2006/main">
               <a:ext uri="{FF2B5EF4-FFF2-40B4-BE49-F238E27FC236}">
-                <a16:creationId xmlns:a16="http://schemas.microsoft.com/office/drawing/2014/main" id="{3A2F078A-F5AA-4845-B985-723C7500281F}"/>
+                <a16:creationId xmlns:a16="http://schemas.microsoft.com/office/drawing/2014/main" id="{69B45FB1-3FE5-4A0F-ADC9-2B3429F15083}"/>
               </a:ext>
             </a:extLst>
           </p:cNvPr>
@@ -7128,7 +7128,7 @@
           <p:cNvPr id="34" name="">
             <a:extLst xmlns:a="http://schemas.openxmlformats.org/drawingml/2006/main">
               <a:ext uri="{FF2B5EF4-FFF2-40B4-BE49-F238E27FC236}">
-                <a16:creationId xmlns:a16="http://schemas.microsoft.com/office/drawing/2014/main" id="{F73161FF-3F2D-4B05-94FB-3AF96854DFCE}"/>
+                <a16:creationId xmlns:a16="http://schemas.microsoft.com/office/drawing/2014/main" id="{A9803A64-43BF-4CB8-B866-54C994700DA9}"/>
               </a:ext>
             </a:extLst>
           </p:cNvPr>
@@ -7190,7 +7190,7 @@
     </p:spTree>
     <p:extLst>
       <p:ext uri="{BB962C8B-B14F-4D97-AF65-F5344CB8AC3E}">
-        <p14:creationId xmlns:p14="http://schemas.microsoft.com/office/powerpoint/2010/main" val="681509094"/>
+        <p14:creationId xmlns:p14="http://schemas.microsoft.com/office/powerpoint/2010/main" val="722346134"/>
       </p:ext>
     </p:extLst>
   </p:cSld>
@@ -7214,7 +7214,7 @@
           <p:cNvPr id="1" name="">
             <a:extLst xmlns:a="http://schemas.openxmlformats.org/drawingml/2006/main">
               <a:ext uri="{FF2B5EF4-FFF2-40B4-BE49-F238E27FC236}">
-                <a16:creationId xmlns:a16="http://schemas.microsoft.com/office/drawing/2014/main" id="{E71866EB-E5D2-4C13-A58F-762B865FDD70}"/>
+                <a16:creationId xmlns:a16="http://schemas.microsoft.com/office/drawing/2014/main" id="{5E32A951-85ED-4269-BB0C-73919C9BD8B6}"/>
               </a:ext>
             </a:extLst>
           </p:cNvPr>
@@ -7246,7 +7246,7 @@
           <p:cNvPr id="2" name="">
             <a:extLst xmlns:a="http://schemas.openxmlformats.org/drawingml/2006/main">
               <a:ext uri="{FF2B5EF4-FFF2-40B4-BE49-F238E27FC236}">
-                <a16:creationId xmlns:a16="http://schemas.microsoft.com/office/drawing/2014/main" id="{EF20404B-C9D6-4B56-9D27-55B00F9DC0A8}"/>
+                <a16:creationId xmlns:a16="http://schemas.microsoft.com/office/drawing/2014/main" id="{922C9A0A-E7AB-42D9-A3D4-2A2C12447F0D}"/>
               </a:ext>
             </a:extLst>
           </p:cNvPr>
@@ -7310,7 +7310,7 @@
           <p:cNvPr id="3" name="">
             <a:extLst xmlns:a="http://schemas.openxmlformats.org/drawingml/2006/main">
               <a:ext uri="{FF2B5EF4-FFF2-40B4-BE49-F238E27FC236}">
-                <a16:creationId xmlns:a16="http://schemas.microsoft.com/office/drawing/2014/main" id="{6D880FAF-BCC2-4B3F-8AC3-35C961351E64}"/>
+                <a16:creationId xmlns:a16="http://schemas.microsoft.com/office/drawing/2014/main" id="{77CCF8DE-862E-4F14-ABE2-C52096C1EB6D}"/>
               </a:ext>
             </a:extLst>
           </p:cNvPr>
@@ -7374,7 +7374,7 @@
           <p:cNvPr id="4" name="">
             <a:extLst xmlns:a="http://schemas.openxmlformats.org/drawingml/2006/main">
               <a:ext uri="{FF2B5EF4-FFF2-40B4-BE49-F238E27FC236}">
-                <a16:creationId xmlns:a16="http://schemas.microsoft.com/office/drawing/2014/main" id="{B37F4947-D7CE-490F-B5EF-D577B178646B}"/>
+                <a16:creationId xmlns:a16="http://schemas.microsoft.com/office/drawing/2014/main" id="{6636A11E-503E-4469-8CB3-AAEF2C410197}"/>
               </a:ext>
             </a:extLst>
           </p:cNvPr>
@@ -7406,7 +7406,7 @@
           <p:cNvPr id="5" name="">
             <a:extLst xmlns:a="http://schemas.openxmlformats.org/drawingml/2006/main">
               <a:ext uri="{FF2B5EF4-FFF2-40B4-BE49-F238E27FC236}">
-                <a16:creationId xmlns:a16="http://schemas.microsoft.com/office/drawing/2014/main" id="{02E20245-1656-47DF-BD2C-95F138D47278}"/>
+                <a16:creationId xmlns:a16="http://schemas.microsoft.com/office/drawing/2014/main" id="{7D3C98DE-DB1F-4AEB-8C6A-0BB1A553BFB9}"/>
               </a:ext>
             </a:extLst>
           </p:cNvPr>
@@ -7438,7 +7438,7 @@
           <p:cNvPr id="6" name="">
             <a:extLst xmlns:a="http://schemas.openxmlformats.org/drawingml/2006/main">
               <a:ext uri="{FF2B5EF4-FFF2-40B4-BE49-F238E27FC236}">
-                <a16:creationId xmlns:a16="http://schemas.microsoft.com/office/drawing/2014/main" id="{9DDC33F8-7CE7-48E9-A8D5-26A3DA28D49B}"/>
+                <a16:creationId xmlns:a16="http://schemas.microsoft.com/office/drawing/2014/main" id="{5820FCC8-2366-4AA4-ADA9-123BBD459076}"/>
               </a:ext>
             </a:extLst>
           </p:cNvPr>
@@ -7502,7 +7502,7 @@
           <p:cNvPr id="7" name="">
             <a:extLst xmlns:a="http://schemas.openxmlformats.org/drawingml/2006/main">
               <a:ext uri="{FF2B5EF4-FFF2-40B4-BE49-F238E27FC236}">
-                <a16:creationId xmlns:a16="http://schemas.microsoft.com/office/drawing/2014/main" id="{7B4C60CC-7665-44A6-945F-6FEB958E5249}"/>
+                <a16:creationId xmlns:a16="http://schemas.microsoft.com/office/drawing/2014/main" id="{7AB75C5A-E0F4-4530-8500-A30BAD60C698}"/>
               </a:ext>
             </a:extLst>
           </p:cNvPr>
@@ -7534,7 +7534,7 @@
           <p:cNvPr id="8" name="">
             <a:extLst xmlns:a="http://schemas.openxmlformats.org/drawingml/2006/main">
               <a:ext uri="{FF2B5EF4-FFF2-40B4-BE49-F238E27FC236}">
-                <a16:creationId xmlns:a16="http://schemas.microsoft.com/office/drawing/2014/main" id="{A806DA17-902D-4DBA-8C89-009F73944E45}"/>
+                <a16:creationId xmlns:a16="http://schemas.microsoft.com/office/drawing/2014/main" id="{7B75BDD3-156B-4202-8A9D-0163F22FDA5D}"/>
               </a:ext>
             </a:extLst>
           </p:cNvPr>
@@ -7566,7 +7566,7 @@
           <p:cNvPr id="9" name="">
             <a:extLst xmlns:a="http://schemas.openxmlformats.org/drawingml/2006/main">
               <a:ext uri="{FF2B5EF4-FFF2-40B4-BE49-F238E27FC236}">
-                <a16:creationId xmlns:a16="http://schemas.microsoft.com/office/drawing/2014/main" id="{F2F39314-A398-4E4D-9FFE-A1BC04F4DE4B}"/>
+                <a16:creationId xmlns:a16="http://schemas.microsoft.com/office/drawing/2014/main" id="{7189E8FA-A627-47C6-BBDF-CF8872FAE6B9}"/>
               </a:ext>
             </a:extLst>
           </p:cNvPr>
@@ -7630,7 +7630,7 @@
           <p:cNvPr id="10" name="">
             <a:extLst xmlns:a="http://schemas.openxmlformats.org/drawingml/2006/main">
               <a:ext uri="{FF2B5EF4-FFF2-40B4-BE49-F238E27FC236}">
-                <a16:creationId xmlns:a16="http://schemas.microsoft.com/office/drawing/2014/main" id="{C709E239-7CD0-46BC-B10C-23FBD6F29813}"/>
+                <a16:creationId xmlns:a16="http://schemas.microsoft.com/office/drawing/2014/main" id="{EF862ABF-DE80-4FB5-AF3B-D9D4AD813465}"/>
               </a:ext>
             </a:extLst>
           </p:cNvPr>
@@ -7662,7 +7662,7 @@
           <p:cNvPr id="11" name="">
             <a:extLst xmlns:a="http://schemas.openxmlformats.org/drawingml/2006/main">
               <a:ext uri="{FF2B5EF4-FFF2-40B4-BE49-F238E27FC236}">
-                <a16:creationId xmlns:a16="http://schemas.microsoft.com/office/drawing/2014/main" id="{16FE4DD6-3435-4E3F-9A21-5F8962D96FC6}"/>
+                <a16:creationId xmlns:a16="http://schemas.microsoft.com/office/drawing/2014/main" id="{1152DCD2-4911-449C-91E1-FBEE35F37F41}"/>
               </a:ext>
             </a:extLst>
           </p:cNvPr>
@@ -7694,7 +7694,7 @@
           <p:cNvPr id="12" name="">
             <a:extLst xmlns:a="http://schemas.openxmlformats.org/drawingml/2006/main">
               <a:ext uri="{FF2B5EF4-FFF2-40B4-BE49-F238E27FC236}">
-                <a16:creationId xmlns:a16="http://schemas.microsoft.com/office/drawing/2014/main" id="{6F446BE1-6FEA-48F0-83A2-EEE09213EBD3}"/>
+                <a16:creationId xmlns:a16="http://schemas.microsoft.com/office/drawing/2014/main" id="{FC9B502B-95D3-4184-921D-3BEF406DD643}"/>
               </a:ext>
             </a:extLst>
           </p:cNvPr>
@@ -7758,7 +7758,7 @@
           <p:cNvPr id="13" name="">
             <a:extLst xmlns:a="http://schemas.openxmlformats.org/drawingml/2006/main">
               <a:ext uri="{FF2B5EF4-FFF2-40B4-BE49-F238E27FC236}">
-                <a16:creationId xmlns:a16="http://schemas.microsoft.com/office/drawing/2014/main" id="{4BD30350-EBE7-4710-9FAA-309BB12A122E}"/>
+                <a16:creationId xmlns:a16="http://schemas.microsoft.com/office/drawing/2014/main" id="{C83CC6A7-19ED-416C-8E07-8E0B575C5D36}"/>
               </a:ext>
             </a:extLst>
           </p:cNvPr>
@@ -7790,7 +7790,7 @@
           <p:cNvPr id="14" name="">
             <a:extLst xmlns:a="http://schemas.openxmlformats.org/drawingml/2006/main">
               <a:ext uri="{FF2B5EF4-FFF2-40B4-BE49-F238E27FC236}">
-                <a16:creationId xmlns:a16="http://schemas.microsoft.com/office/drawing/2014/main" id="{3854FAFC-F4DE-417B-85AA-D80E300858EE}"/>
+                <a16:creationId xmlns:a16="http://schemas.microsoft.com/office/drawing/2014/main" id="{09B346CF-0976-45E6-9349-1DB30687D682}"/>
               </a:ext>
             </a:extLst>
           </p:cNvPr>
@@ -7822,7 +7822,7 @@
           <p:cNvPr id="15" name="">
             <a:extLst xmlns:a="http://schemas.openxmlformats.org/drawingml/2006/main">
               <a:ext uri="{FF2B5EF4-FFF2-40B4-BE49-F238E27FC236}">
-                <a16:creationId xmlns:a16="http://schemas.microsoft.com/office/drawing/2014/main" id="{88AC0FA6-D21E-41D6-B471-740A66AE747D}"/>
+                <a16:creationId xmlns:a16="http://schemas.microsoft.com/office/drawing/2014/main" id="{B5433D18-3BD7-4597-8D8E-CD451419B9B3}"/>
               </a:ext>
             </a:extLst>
           </p:cNvPr>
@@ -7886,7 +7886,7 @@
           <p:cNvPr id="16" name="">
             <a:extLst xmlns:a="http://schemas.openxmlformats.org/drawingml/2006/main">
               <a:ext uri="{FF2B5EF4-FFF2-40B4-BE49-F238E27FC236}">
-                <a16:creationId xmlns:a16="http://schemas.microsoft.com/office/drawing/2014/main" id="{7566DC91-2B8E-4205-BF80-9CE343844C0B}"/>
+                <a16:creationId xmlns:a16="http://schemas.microsoft.com/office/drawing/2014/main" id="{6BC12517-AD7D-4730-8870-A9D422A0C023}"/>
               </a:ext>
             </a:extLst>
           </p:cNvPr>
@@ -7918,7 +7918,7 @@
           <p:cNvPr id="17" name="">
             <a:extLst xmlns:a="http://schemas.openxmlformats.org/drawingml/2006/main">
               <a:ext uri="{FF2B5EF4-FFF2-40B4-BE49-F238E27FC236}">
-                <a16:creationId xmlns:a16="http://schemas.microsoft.com/office/drawing/2014/main" id="{9A2A6708-375A-4E85-8B56-940FF08B435F}"/>
+                <a16:creationId xmlns:a16="http://schemas.microsoft.com/office/drawing/2014/main" id="{D133FDCF-8AE1-4060-A557-DCEB30439A48}"/>
               </a:ext>
             </a:extLst>
           </p:cNvPr>
@@ -7950,7 +7950,7 @@
           <p:cNvPr id="18" name="">
             <a:extLst xmlns:a="http://schemas.openxmlformats.org/drawingml/2006/main">
               <a:ext uri="{FF2B5EF4-FFF2-40B4-BE49-F238E27FC236}">
-                <a16:creationId xmlns:a16="http://schemas.microsoft.com/office/drawing/2014/main" id="{7CAD5C2D-A00F-42BB-BA63-05B806442531}"/>
+                <a16:creationId xmlns:a16="http://schemas.microsoft.com/office/drawing/2014/main" id="{EEBB3E99-9E13-4226-9431-F89B2CD0AF0E}"/>
               </a:ext>
             </a:extLst>
           </p:cNvPr>
@@ -8014,7 +8014,7 @@
           <p:cNvPr id="19" name="">
             <a:extLst xmlns:a="http://schemas.openxmlformats.org/drawingml/2006/main">
               <a:ext uri="{FF2B5EF4-FFF2-40B4-BE49-F238E27FC236}">
-                <a16:creationId xmlns:a16="http://schemas.microsoft.com/office/drawing/2014/main" id="{6B9386AC-6A28-4D1B-8E22-315ACA64976A}"/>
+                <a16:creationId xmlns:a16="http://schemas.microsoft.com/office/drawing/2014/main" id="{4A3BB254-0D91-4E68-93B9-052AC44123C9}"/>
               </a:ext>
             </a:extLst>
           </p:cNvPr>
@@ -8046,7 +8046,7 @@
           <p:cNvPr id="20" name="">
             <a:extLst xmlns:a="http://schemas.openxmlformats.org/drawingml/2006/main">
               <a:ext uri="{FF2B5EF4-FFF2-40B4-BE49-F238E27FC236}">
-                <a16:creationId xmlns:a16="http://schemas.microsoft.com/office/drawing/2014/main" id="{8689F21E-DD74-468C-875A-B68840BAA410}"/>
+                <a16:creationId xmlns:a16="http://schemas.microsoft.com/office/drawing/2014/main" id="{EB291605-F6EE-4334-864E-A97356A9B242}"/>
               </a:ext>
             </a:extLst>
           </p:cNvPr>
@@ -8078,7 +8078,7 @@
           <p:cNvPr id="21" name="">
             <a:extLst xmlns:a="http://schemas.openxmlformats.org/drawingml/2006/main">
               <a:ext uri="{FF2B5EF4-FFF2-40B4-BE49-F238E27FC236}">
-                <a16:creationId xmlns:a16="http://schemas.microsoft.com/office/drawing/2014/main" id="{DECCF47C-4F2E-4A68-A2A7-4751EFB221BA}"/>
+                <a16:creationId xmlns:a16="http://schemas.microsoft.com/office/drawing/2014/main" id="{AA697118-197F-4748-ADFC-7BDE754C5FE3}"/>
               </a:ext>
             </a:extLst>
           </p:cNvPr>
@@ -8142,7 +8142,7 @@
           <p:cNvPr id="22" name="">
             <a:extLst xmlns:a="http://schemas.openxmlformats.org/drawingml/2006/main">
               <a:ext uri="{FF2B5EF4-FFF2-40B4-BE49-F238E27FC236}">
-                <a16:creationId xmlns:a16="http://schemas.microsoft.com/office/drawing/2014/main" id="{9D3253B1-CAC2-44F0-BA8F-DB6A5477E792}"/>
+                <a16:creationId xmlns:a16="http://schemas.microsoft.com/office/drawing/2014/main" id="{889DB5C1-04C0-4F29-A313-7267C7932AD0}"/>
               </a:ext>
             </a:extLst>
           </p:cNvPr>
@@ -8174,7 +8174,7 @@
           <p:cNvPr id="23" name="">
             <a:extLst xmlns:a="http://schemas.openxmlformats.org/drawingml/2006/main">
               <a:ext uri="{FF2B5EF4-FFF2-40B4-BE49-F238E27FC236}">
-                <a16:creationId xmlns:a16="http://schemas.microsoft.com/office/drawing/2014/main" id="{1CF2092D-B73F-429E-9442-14C45979799D}"/>
+                <a16:creationId xmlns:a16="http://schemas.microsoft.com/office/drawing/2014/main" id="{A0CFB24B-147B-4BF2-BEBA-420D98D122BD}"/>
               </a:ext>
             </a:extLst>
           </p:cNvPr>
@@ -8206,7 +8206,7 @@
           <p:cNvPr id="24" name="">
             <a:extLst xmlns:a="http://schemas.openxmlformats.org/drawingml/2006/main">
               <a:ext uri="{FF2B5EF4-FFF2-40B4-BE49-F238E27FC236}">
-                <a16:creationId xmlns:a16="http://schemas.microsoft.com/office/drawing/2014/main" id="{26EB5E7C-C714-4868-ACFE-302F4A79F531}"/>
+                <a16:creationId xmlns:a16="http://schemas.microsoft.com/office/drawing/2014/main" id="{D3CAEC51-496A-4081-A615-C2770A01DF09}"/>
               </a:ext>
             </a:extLst>
           </p:cNvPr>
@@ -8270,7 +8270,7 @@
           <p:cNvPr id="25" name="">
             <a:extLst xmlns:a="http://schemas.openxmlformats.org/drawingml/2006/main">
               <a:ext uri="{FF2B5EF4-FFF2-40B4-BE49-F238E27FC236}">
-                <a16:creationId xmlns:a16="http://schemas.microsoft.com/office/drawing/2014/main" id="{9B103A4A-16D3-44D6-B198-32E96DCA69BF}"/>
+                <a16:creationId xmlns:a16="http://schemas.microsoft.com/office/drawing/2014/main" id="{7D3655F3-0E02-4FCC-B962-C2E9CD672B84}"/>
               </a:ext>
             </a:extLst>
           </p:cNvPr>
@@ -8334,7 +8334,7 @@
           <p:cNvPr id="26" name="">
             <a:extLst xmlns:a="http://schemas.openxmlformats.org/drawingml/2006/main">
               <a:ext uri="{FF2B5EF4-FFF2-40B4-BE49-F238E27FC236}">
-                <a16:creationId xmlns:a16="http://schemas.microsoft.com/office/drawing/2014/main" id="{A59E8139-A6F6-4EA2-B5EC-6B77F55DFA6B}"/>
+                <a16:creationId xmlns:a16="http://schemas.microsoft.com/office/drawing/2014/main" id="{EB2BCBC7-6E64-4E65-B92C-74F6F8D472E8}"/>
               </a:ext>
             </a:extLst>
           </p:cNvPr>
@@ -8398,7 +8398,7 @@
           <p:cNvPr id="27" name="">
             <a:extLst xmlns:a="http://schemas.openxmlformats.org/drawingml/2006/main">
               <a:ext uri="{FF2B5EF4-FFF2-40B4-BE49-F238E27FC236}">
-                <a16:creationId xmlns:a16="http://schemas.microsoft.com/office/drawing/2014/main" id="{31CA8463-A7C2-4EC3-9772-783099D7508C}"/>
+                <a16:creationId xmlns:a16="http://schemas.microsoft.com/office/drawing/2014/main" id="{90701355-1EFF-4049-A858-EFA3C9600821}"/>
               </a:ext>
             </a:extLst>
           </p:cNvPr>
@@ -8462,7 +8462,7 @@
           <p:cNvPr id="28" name="">
             <a:extLst xmlns:a="http://schemas.openxmlformats.org/drawingml/2006/main">
               <a:ext uri="{FF2B5EF4-FFF2-40B4-BE49-F238E27FC236}">
-                <a16:creationId xmlns:a16="http://schemas.microsoft.com/office/drawing/2014/main" id="{0AD28180-D623-41CC-A1FC-C67CCBC809CE}"/>
+                <a16:creationId xmlns:a16="http://schemas.microsoft.com/office/drawing/2014/main" id="{6F6E6413-3AF3-4DB9-97D5-93F3DCCC0055}"/>
               </a:ext>
             </a:extLst>
           </p:cNvPr>
@@ -8524,7 +8524,7 @@
     </p:spTree>
     <p:extLst>
       <p:ext uri="{BB962C8B-B14F-4D97-AF65-F5344CB8AC3E}">
-        <p14:creationId xmlns:p14="http://schemas.microsoft.com/office/powerpoint/2010/main" val="947057769"/>
+        <p14:creationId xmlns:p14="http://schemas.microsoft.com/office/powerpoint/2010/main" val="82130809"/>
       </p:ext>
     </p:extLst>
   </p:cSld>
@@ -8548,7 +8548,7 @@
           <p:cNvPr id="1" name="">
             <a:extLst xmlns:a="http://schemas.openxmlformats.org/drawingml/2006/main">
               <a:ext uri="{FF2B5EF4-FFF2-40B4-BE49-F238E27FC236}">
-                <a16:creationId xmlns:a16="http://schemas.microsoft.com/office/drawing/2014/main" id="{9785219E-A25A-4FBE-B34A-6EC0C7D0F03C}"/>
+                <a16:creationId xmlns:a16="http://schemas.microsoft.com/office/drawing/2014/main" id="{972656D1-6676-4D72-9940-1FEE374B37D2}"/>
               </a:ext>
             </a:extLst>
           </p:cNvPr>
@@ -8580,7 +8580,7 @@
           <p:cNvPr id="2" name="">
             <a:extLst xmlns:a="http://schemas.openxmlformats.org/drawingml/2006/main">
               <a:ext uri="{FF2B5EF4-FFF2-40B4-BE49-F238E27FC236}">
-                <a16:creationId xmlns:a16="http://schemas.microsoft.com/office/drawing/2014/main" id="{3374BB89-05AE-4024-A5FA-AB92ECAD19E9}"/>
+                <a16:creationId xmlns:a16="http://schemas.microsoft.com/office/drawing/2014/main" id="{F8210BFB-2205-423D-8095-625874E14911}"/>
               </a:ext>
             </a:extLst>
           </p:cNvPr>
@@ -8644,7 +8644,7 @@
           <p:cNvPr id="3" name="">
             <a:extLst xmlns:a="http://schemas.openxmlformats.org/drawingml/2006/main">
               <a:ext uri="{FF2B5EF4-FFF2-40B4-BE49-F238E27FC236}">
-                <a16:creationId xmlns:a16="http://schemas.microsoft.com/office/drawing/2014/main" id="{20E72B09-AB57-4694-98BD-AC39E79E9365}"/>
+                <a16:creationId xmlns:a16="http://schemas.microsoft.com/office/drawing/2014/main" id="{E05DC359-ED70-4FE4-B95F-2393973FFCB8}"/>
               </a:ext>
             </a:extLst>
           </p:cNvPr>
@@ -8708,7 +8708,7 @@
           <p:cNvPr id="4" name="">
             <a:extLst xmlns:a="http://schemas.openxmlformats.org/drawingml/2006/main">
               <a:ext uri="{FF2B5EF4-FFF2-40B4-BE49-F238E27FC236}">
-                <a16:creationId xmlns:a16="http://schemas.microsoft.com/office/drawing/2014/main" id="{AC8ABB07-810F-4F39-B8B0-D25D8FD8A03E}"/>
+                <a16:creationId xmlns:a16="http://schemas.microsoft.com/office/drawing/2014/main" id="{AE7E6DA6-DDB1-4895-A91C-3F01DC5ECC25}"/>
               </a:ext>
             </a:extLst>
           </p:cNvPr>
@@ -8744,13 +8744,13 @@
           <p:nvPr/>
         </p:nvPicPr>
         <p:blipFill>
-          <a:blip xmlns:r="http://schemas.openxmlformats.org/officeDocument/2006/relationships" xmlns:a="http://schemas.openxmlformats.org/drawingml/2006/main" r:embed="R49112b29261846a7"/>
+          <a:blip xmlns:r="http://schemas.openxmlformats.org/officeDocument/2006/relationships" xmlns:a="http://schemas.openxmlformats.org/drawingml/2006/main" r:embed="Ra05164f5977e4afa"/>
           <a:stretch xmlns:a="http://schemas.openxmlformats.org/drawingml/2006/main"/>
         </p:blipFill>
         <p:spPr>
           <a:xfrm xmlns:a="http://schemas.openxmlformats.org/drawingml/2006/main">
-            <a:off x="552450" y="1977102"/>
-            <a:ext cx="3476625" cy="1656020"/>
+            <a:off x="552450" y="1976254"/>
+            <a:ext cx="3476625" cy="1657717"/>
           </a:xfrm>
           <a:prstGeom xmlns:a="http://schemas.openxmlformats.org/drawingml/2006/main" prst="rect">
             <a:avLst/>
@@ -8766,13 +8766,13 @@
           <p:nvPr/>
         </p:nvPicPr>
         <p:blipFill>
-          <a:blip xmlns:r="http://schemas.openxmlformats.org/officeDocument/2006/relationships" xmlns:a="http://schemas.openxmlformats.org/drawingml/2006/main" r:embed="R46f3043a7bbc4e11"/>
+          <a:blip xmlns:r="http://schemas.openxmlformats.org/officeDocument/2006/relationships" xmlns:a="http://schemas.openxmlformats.org/drawingml/2006/main" r:embed="R058791170dc44051"/>
           <a:stretch xmlns:a="http://schemas.openxmlformats.org/drawingml/2006/main"/>
         </p:blipFill>
         <p:spPr>
           <a:xfrm xmlns:a="http://schemas.openxmlformats.org/drawingml/2006/main">
-            <a:off x="4343400" y="1797531"/>
-            <a:ext cx="3333750" cy="2015164"/>
+            <a:off x="4343400" y="1796621"/>
+            <a:ext cx="3333750" cy="2016982"/>
           </a:xfrm>
           <a:prstGeom xmlns:a="http://schemas.openxmlformats.org/drawingml/2006/main" prst="rect">
             <a:avLst/>
@@ -8788,13 +8788,13 @@
           <p:nvPr/>
         </p:nvPicPr>
         <p:blipFill>
-          <a:blip xmlns:r="http://schemas.openxmlformats.org/officeDocument/2006/relationships" xmlns:a="http://schemas.openxmlformats.org/drawingml/2006/main" r:embed="Re5318dcaaab64951"/>
+          <a:blip xmlns:r="http://schemas.openxmlformats.org/officeDocument/2006/relationships" xmlns:a="http://schemas.openxmlformats.org/drawingml/2006/main" r:embed="R67a742bdcd3f402c"/>
           <a:stretch xmlns:a="http://schemas.openxmlformats.org/drawingml/2006/main"/>
         </p:blipFill>
         <p:spPr>
           <a:xfrm xmlns:a="http://schemas.openxmlformats.org/drawingml/2006/main">
-            <a:off x="8001000" y="1624462"/>
-            <a:ext cx="3429000" cy="2361300"/>
+            <a:off x="8001000" y="1623397"/>
+            <a:ext cx="3429000" cy="2363431"/>
           </a:xfrm>
           <a:prstGeom xmlns:a="http://schemas.openxmlformats.org/drawingml/2006/main" prst="rect">
             <a:avLst/>
@@ -8806,7 +8806,7 @@
           <p:cNvPr id="8" name="">
             <a:extLst xmlns:a="http://schemas.openxmlformats.org/drawingml/2006/main">
               <a:ext uri="{FF2B5EF4-FFF2-40B4-BE49-F238E27FC236}">
-                <a16:creationId xmlns:a16="http://schemas.microsoft.com/office/drawing/2014/main" id="{75E27226-742E-4840-AA2E-8C61E559188A}"/>
+                <a16:creationId xmlns:a16="http://schemas.microsoft.com/office/drawing/2014/main" id="{B8EA7E8D-5918-4EB7-9D52-471F1E7C6C50}"/>
               </a:ext>
             </a:extLst>
           </p:cNvPr>
@@ -8860,7 +8860,7 @@
                 <a:ea typeface="Microsoft YaHei"/>
                 <a:cs typeface="Microsoft YaHei"/>
               </a:rPr>
-              <a:t>样本：2024年1-3月，前15个机场，224,755条记录。航班量高不等于延误率最高，恢复决策需要结合网络位置和运行状态。</a:t>
+              <a:t>样本：2024年1-3月，前30个机场，610,640条记录。航班量高不等于延误率最高，恢复决策需要结合网络位置和运行状态。</a:t>
             </a:r>
           </a:p>
         </p:txBody>
@@ -8870,7 +8870,7 @@
           <p:cNvPr id="9" name="">
             <a:extLst xmlns:a="http://schemas.openxmlformats.org/drawingml/2006/main">
               <a:ext uri="{FF2B5EF4-FFF2-40B4-BE49-F238E27FC236}">
-                <a16:creationId xmlns:a16="http://schemas.microsoft.com/office/drawing/2014/main" id="{97B92AA0-95A4-4974-B909-D393E13AD893}"/>
+                <a16:creationId xmlns:a16="http://schemas.microsoft.com/office/drawing/2014/main" id="{C86522E1-4300-438A-B88E-E195A3F40448}"/>
               </a:ext>
             </a:extLst>
           </p:cNvPr>
@@ -8934,7 +8934,7 @@
           <p:cNvPr id="10" name="">
             <a:extLst xmlns:a="http://schemas.openxmlformats.org/drawingml/2006/main">
               <a:ext uri="{FF2B5EF4-FFF2-40B4-BE49-F238E27FC236}">
-                <a16:creationId xmlns:a16="http://schemas.microsoft.com/office/drawing/2014/main" id="{C02FE77B-4216-44F5-B000-B839146DF520}"/>
+                <a16:creationId xmlns:a16="http://schemas.microsoft.com/office/drawing/2014/main" id="{7D6A6527-D6F6-4711-B01E-9F94DA72B13C}"/>
               </a:ext>
             </a:extLst>
           </p:cNvPr>
@@ -8996,7 +8996,7 @@
     </p:spTree>
     <p:extLst>
       <p:ext uri="{BB962C8B-B14F-4D97-AF65-F5344CB8AC3E}">
-        <p14:creationId xmlns:p14="http://schemas.microsoft.com/office/powerpoint/2010/main" val="93342506"/>
+        <p14:creationId xmlns:p14="http://schemas.microsoft.com/office/powerpoint/2010/main" val="1253131466"/>
       </p:ext>
     </p:extLst>
   </p:cSld>
@@ -9020,7 +9020,7 @@
           <p:cNvPr id="1" name="">
             <a:extLst xmlns:a="http://schemas.openxmlformats.org/drawingml/2006/main">
               <a:ext uri="{FF2B5EF4-FFF2-40B4-BE49-F238E27FC236}">
-                <a16:creationId xmlns:a16="http://schemas.microsoft.com/office/drawing/2014/main" id="{BA88625C-4925-4048-A747-35E3C20989E7}"/>
+                <a16:creationId xmlns:a16="http://schemas.microsoft.com/office/drawing/2014/main" id="{3F298F30-2468-4A37-BD77-0B07F98F7AE0}"/>
               </a:ext>
             </a:extLst>
           </p:cNvPr>
@@ -9052,7 +9052,7 @@
           <p:cNvPr id="2" name="">
             <a:extLst xmlns:a="http://schemas.openxmlformats.org/drawingml/2006/main">
               <a:ext uri="{FF2B5EF4-FFF2-40B4-BE49-F238E27FC236}">
-                <a16:creationId xmlns:a16="http://schemas.microsoft.com/office/drawing/2014/main" id="{5BE76A49-1CC1-4B9A-A6D0-9C684D161086}"/>
+                <a16:creationId xmlns:a16="http://schemas.microsoft.com/office/drawing/2014/main" id="{F03728A7-816A-448D-B092-CF810731C39C}"/>
               </a:ext>
             </a:extLst>
           </p:cNvPr>
@@ -9116,7 +9116,7 @@
           <p:cNvPr id="3" name="">
             <a:extLst xmlns:a="http://schemas.openxmlformats.org/drawingml/2006/main">
               <a:ext uri="{FF2B5EF4-FFF2-40B4-BE49-F238E27FC236}">
-                <a16:creationId xmlns:a16="http://schemas.microsoft.com/office/drawing/2014/main" id="{1D6C340A-2865-487D-909C-2ABA4BB0668C}"/>
+                <a16:creationId xmlns:a16="http://schemas.microsoft.com/office/drawing/2014/main" id="{3C612B2C-5BA0-472F-87B1-22E9548EE652}"/>
               </a:ext>
             </a:extLst>
           </p:cNvPr>
@@ -9180,7 +9180,7 @@
           <p:cNvPr id="4" name="">
             <a:extLst xmlns:a="http://schemas.openxmlformats.org/drawingml/2006/main">
               <a:ext uri="{FF2B5EF4-FFF2-40B4-BE49-F238E27FC236}">
-                <a16:creationId xmlns:a16="http://schemas.microsoft.com/office/drawing/2014/main" id="{8E85CC03-9C1B-44DA-AA00-932E6C5E3DA7}"/>
+                <a16:creationId xmlns:a16="http://schemas.microsoft.com/office/drawing/2014/main" id="{082B1923-145B-4345-9A6C-D8B576A36845}"/>
               </a:ext>
             </a:extLst>
           </p:cNvPr>
@@ -9216,13 +9216,13 @@
           <p:nvPr/>
         </p:nvPicPr>
         <p:blipFill>
-          <a:blip xmlns:r="http://schemas.openxmlformats.org/officeDocument/2006/relationships" xmlns:a="http://schemas.openxmlformats.org/drawingml/2006/main" r:embed="R0e26f2880b7345bb"/>
+          <a:blip xmlns:r="http://schemas.openxmlformats.org/officeDocument/2006/relationships" xmlns:a="http://schemas.openxmlformats.org/drawingml/2006/main" r:embed="R8f7d1e0bd0984a19"/>
           <a:stretch xmlns:a="http://schemas.openxmlformats.org/drawingml/2006/main"/>
         </p:blipFill>
         <p:spPr>
           <a:xfrm xmlns:a="http://schemas.openxmlformats.org/drawingml/2006/main">
-            <a:off x="666750" y="1711330"/>
-            <a:ext cx="5810250" cy="3549639"/>
+            <a:off x="666750" y="1709727"/>
+            <a:ext cx="5810250" cy="3552846"/>
           </a:xfrm>
           <a:prstGeom xmlns:a="http://schemas.openxmlformats.org/drawingml/2006/main" prst="rect">
             <a:avLst/>
@@ -9238,13 +9238,13 @@
           <p:nvPr/>
         </p:nvPicPr>
         <p:blipFill>
-          <a:blip xmlns:r="http://schemas.openxmlformats.org/officeDocument/2006/relationships" xmlns:a="http://schemas.openxmlformats.org/drawingml/2006/main" r:embed="Rf3fe6ac0516e417f"/>
+          <a:blip xmlns:r="http://schemas.openxmlformats.org/officeDocument/2006/relationships" xmlns:a="http://schemas.openxmlformats.org/drawingml/2006/main" r:embed="R88b2fce84a2e4d38"/>
           <a:stretch xmlns:a="http://schemas.openxmlformats.org/drawingml/2006/main"/>
         </p:blipFill>
         <p:spPr>
           <a:xfrm xmlns:a="http://schemas.openxmlformats.org/drawingml/2006/main">
-            <a:off x="7234970" y="1619250"/>
-            <a:ext cx="3341809" cy="3333750"/>
+            <a:off x="7239000" y="1619250"/>
+            <a:ext cx="3333750" cy="3333750"/>
           </a:xfrm>
           <a:prstGeom xmlns:a="http://schemas.openxmlformats.org/drawingml/2006/main" prst="rect">
             <a:avLst/>
@@ -9256,7 +9256,7 @@
           <p:cNvPr id="7" name="">
             <a:extLst xmlns:a="http://schemas.openxmlformats.org/drawingml/2006/main">
               <a:ext uri="{FF2B5EF4-FFF2-40B4-BE49-F238E27FC236}">
-                <a16:creationId xmlns:a16="http://schemas.microsoft.com/office/drawing/2014/main" id="{D36C2D15-6C0E-42EE-BA55-592703301F47}"/>
+                <a16:creationId xmlns:a16="http://schemas.microsoft.com/office/drawing/2014/main" id="{052C1616-9ED0-40A4-A8B2-F5A7DF187CD4}"/>
               </a:ext>
             </a:extLst>
           </p:cNvPr>
@@ -9320,7 +9320,7 @@
           <p:cNvPr id="8" name="">
             <a:extLst xmlns:a="http://schemas.openxmlformats.org/drawingml/2006/main">
               <a:ext uri="{FF2B5EF4-FFF2-40B4-BE49-F238E27FC236}">
-                <a16:creationId xmlns:a16="http://schemas.microsoft.com/office/drawing/2014/main" id="{062FE725-2735-4C42-95CC-2C4F87BDB30D}"/>
+                <a16:creationId xmlns:a16="http://schemas.microsoft.com/office/drawing/2014/main" id="{B55C32D4-5422-4B70-9517-91ACD70F8D27}"/>
               </a:ext>
             </a:extLst>
           </p:cNvPr>
@@ -9384,7 +9384,7 @@
           <p:cNvPr id="9" name="">
             <a:extLst xmlns:a="http://schemas.openxmlformats.org/drawingml/2006/main">
               <a:ext uri="{FF2B5EF4-FFF2-40B4-BE49-F238E27FC236}">
-                <a16:creationId xmlns:a16="http://schemas.microsoft.com/office/drawing/2014/main" id="{E143AC65-847B-405A-9FA5-0E07C191E9A3}"/>
+                <a16:creationId xmlns:a16="http://schemas.microsoft.com/office/drawing/2014/main" id="{CFAF431F-53E7-4482-9B5E-AFA8DC3C695F}"/>
               </a:ext>
             </a:extLst>
           </p:cNvPr>
@@ -9446,7 +9446,7 @@
     </p:spTree>
     <p:extLst>
       <p:ext uri="{BB962C8B-B14F-4D97-AF65-F5344CB8AC3E}">
-        <p14:creationId xmlns:p14="http://schemas.microsoft.com/office/powerpoint/2010/main" val="1169610480"/>
+        <p14:creationId xmlns:p14="http://schemas.microsoft.com/office/powerpoint/2010/main" val="1520723753"/>
       </p:ext>
     </p:extLst>
   </p:cSld>
@@ -9470,7 +9470,7 @@
           <p:cNvPr id="1" name="">
             <a:extLst xmlns:a="http://schemas.openxmlformats.org/drawingml/2006/main">
               <a:ext uri="{FF2B5EF4-FFF2-40B4-BE49-F238E27FC236}">
-                <a16:creationId xmlns:a16="http://schemas.microsoft.com/office/drawing/2014/main" id="{490762E4-F915-4E30-8B83-264032D209AD}"/>
+                <a16:creationId xmlns:a16="http://schemas.microsoft.com/office/drawing/2014/main" id="{08AE375D-7F01-40F0-AB25-6D4D848CC57B}"/>
               </a:ext>
             </a:extLst>
           </p:cNvPr>
@@ -9502,7 +9502,7 @@
           <p:cNvPr id="2" name="">
             <a:extLst xmlns:a="http://schemas.openxmlformats.org/drawingml/2006/main">
               <a:ext uri="{FF2B5EF4-FFF2-40B4-BE49-F238E27FC236}">
-                <a16:creationId xmlns:a16="http://schemas.microsoft.com/office/drawing/2014/main" id="{562A15B7-D643-4E24-BD8B-06360B8129AA}"/>
+                <a16:creationId xmlns:a16="http://schemas.microsoft.com/office/drawing/2014/main" id="{5CC367EB-27A6-460A-A0B1-81BBDE54F75A}"/>
               </a:ext>
             </a:extLst>
           </p:cNvPr>
@@ -9566,7 +9566,7 @@
           <p:cNvPr id="3" name="">
             <a:extLst xmlns:a="http://schemas.openxmlformats.org/drawingml/2006/main">
               <a:ext uri="{FF2B5EF4-FFF2-40B4-BE49-F238E27FC236}">
-                <a16:creationId xmlns:a16="http://schemas.microsoft.com/office/drawing/2014/main" id="{BA4236E0-AE4B-462B-92DE-EA1336A8E89A}"/>
+                <a16:creationId xmlns:a16="http://schemas.microsoft.com/office/drawing/2014/main" id="{91B120AD-9487-4485-8409-A41AD947EE94}"/>
               </a:ext>
             </a:extLst>
           </p:cNvPr>
@@ -9630,7 +9630,7 @@
           <p:cNvPr id="4" name="">
             <a:extLst xmlns:a="http://schemas.openxmlformats.org/drawingml/2006/main">
               <a:ext uri="{FF2B5EF4-FFF2-40B4-BE49-F238E27FC236}">
-                <a16:creationId xmlns:a16="http://schemas.microsoft.com/office/drawing/2014/main" id="{18F86982-D58C-4367-BD5F-58E4F25F97E4}"/>
+                <a16:creationId xmlns:a16="http://schemas.microsoft.com/office/drawing/2014/main" id="{A5421231-558E-4454-932D-876FD4EB84E7}"/>
               </a:ext>
             </a:extLst>
           </p:cNvPr>
@@ -9666,13 +9666,13 @@
           <p:nvPr/>
         </p:nvPicPr>
         <p:blipFill>
-          <a:blip xmlns:r="http://schemas.openxmlformats.org/officeDocument/2006/relationships" xmlns:a="http://schemas.openxmlformats.org/drawingml/2006/main" r:embed="Rfe041fee5dc04ea3"/>
+          <a:blip xmlns:r="http://schemas.openxmlformats.org/officeDocument/2006/relationships" xmlns:a="http://schemas.openxmlformats.org/drawingml/2006/main" r:embed="R5ecc14ac0dcb43e7"/>
           <a:stretch xmlns:a="http://schemas.openxmlformats.org/drawingml/2006/main"/>
         </p:blipFill>
         <p:spPr>
           <a:xfrm xmlns:a="http://schemas.openxmlformats.org/drawingml/2006/main">
-            <a:off x="666750" y="1597042"/>
-            <a:ext cx="4762500" cy="2616166"/>
+            <a:off x="666750" y="1595758"/>
+            <a:ext cx="4762500" cy="2618733"/>
           </a:xfrm>
           <a:prstGeom xmlns:a="http://schemas.openxmlformats.org/drawingml/2006/main" prst="rect">
             <a:avLst/>
@@ -9688,13 +9688,13 @@
           <p:nvPr/>
         </p:nvPicPr>
         <p:blipFill>
-          <a:blip xmlns:r="http://schemas.openxmlformats.org/officeDocument/2006/relationships" xmlns:a="http://schemas.openxmlformats.org/drawingml/2006/main" r:embed="R29e5749c4cce44fd"/>
+          <a:blip xmlns:r="http://schemas.openxmlformats.org/officeDocument/2006/relationships" xmlns:a="http://schemas.openxmlformats.org/drawingml/2006/main" r:embed="R592253401ffe463c"/>
           <a:stretch xmlns:a="http://schemas.openxmlformats.org/drawingml/2006/main"/>
         </p:blipFill>
         <p:spPr>
           <a:xfrm xmlns:a="http://schemas.openxmlformats.org/drawingml/2006/main">
-            <a:off x="6198721" y="1428750"/>
-            <a:ext cx="4747559" cy="2952750"/>
+            <a:off x="6209722" y="1428750"/>
+            <a:ext cx="4725557" cy="2952750"/>
           </a:xfrm>
           <a:prstGeom xmlns:a="http://schemas.openxmlformats.org/drawingml/2006/main" prst="rect">
             <a:avLst/>
@@ -9706,7 +9706,7 @@
           <p:cNvPr id="7" name="">
             <a:extLst xmlns:a="http://schemas.openxmlformats.org/drawingml/2006/main">
               <a:ext uri="{FF2B5EF4-FFF2-40B4-BE49-F238E27FC236}">
-                <a16:creationId xmlns:a16="http://schemas.microsoft.com/office/drawing/2014/main" id="{1BFA5832-D8A1-4F87-9DCA-CF815B82B148}"/>
+                <a16:creationId xmlns:a16="http://schemas.microsoft.com/office/drawing/2014/main" id="{D15260F0-347C-4B8A-ABFB-02BA80A6F8F4}"/>
               </a:ext>
             </a:extLst>
           </p:cNvPr>
@@ -9760,7 +9760,7 @@
                 <a:ea typeface="Microsoft YaHei"/>
                 <a:cs typeface="Microsoft YaHei"/>
               </a:rPr>
-              <a:t>最佳模型：随机森林；测试 ROC-AUC 0.674，PR-AUC 0.382。禁用实际起降、实际延误和原因分解字段，降低泄漏风险。</a:t>
+              <a:t>最佳模型：随机森林；测试 ROC-AUC 0.677，PR-AUC 0.379。禁用实际起降、实际延误和原因分解字段，降低泄漏风险。</a:t>
             </a:r>
           </a:p>
         </p:txBody>
@@ -9770,7 +9770,7 @@
           <p:cNvPr id="8" name="">
             <a:extLst xmlns:a="http://schemas.openxmlformats.org/drawingml/2006/main">
               <a:ext uri="{FF2B5EF4-FFF2-40B4-BE49-F238E27FC236}">
-                <a16:creationId xmlns:a16="http://schemas.microsoft.com/office/drawing/2014/main" id="{90386E2E-CE91-4692-A540-AAC903A88FE9}"/>
+                <a16:creationId xmlns:a16="http://schemas.microsoft.com/office/drawing/2014/main" id="{5164BB3B-8740-41AB-86A2-95C2A7F9F8CC}"/>
               </a:ext>
             </a:extLst>
           </p:cNvPr>
@@ -9834,7 +9834,7 @@
           <p:cNvPr id="9" name="">
             <a:extLst xmlns:a="http://schemas.openxmlformats.org/drawingml/2006/main">
               <a:ext uri="{FF2B5EF4-FFF2-40B4-BE49-F238E27FC236}">
-                <a16:creationId xmlns:a16="http://schemas.microsoft.com/office/drawing/2014/main" id="{2A3B1BF0-102A-4D92-B10C-C224A14893CF}"/>
+                <a16:creationId xmlns:a16="http://schemas.microsoft.com/office/drawing/2014/main" id="{C2A19357-D430-4DB7-816C-C302184A381E}"/>
               </a:ext>
             </a:extLst>
           </p:cNvPr>
@@ -9896,7 +9896,7 @@
     </p:spTree>
     <p:extLst>
       <p:ext uri="{BB962C8B-B14F-4D97-AF65-F5344CB8AC3E}">
-        <p14:creationId xmlns:p14="http://schemas.microsoft.com/office/powerpoint/2010/main" val="6156672"/>
+        <p14:creationId xmlns:p14="http://schemas.microsoft.com/office/powerpoint/2010/main" val="1234120626"/>
       </p:ext>
     </p:extLst>
   </p:cSld>
@@ -9920,7 +9920,7 @@
           <p:cNvPr id="1" name="">
             <a:extLst xmlns:a="http://schemas.openxmlformats.org/drawingml/2006/main">
               <a:ext uri="{FF2B5EF4-FFF2-40B4-BE49-F238E27FC236}">
-                <a16:creationId xmlns:a16="http://schemas.microsoft.com/office/drawing/2014/main" id="{D71395B1-2552-4CF3-AF8A-3F7B0BAAE064}"/>
+                <a16:creationId xmlns:a16="http://schemas.microsoft.com/office/drawing/2014/main" id="{752B192D-C499-4AD9-97B5-3DEF34580B58}"/>
               </a:ext>
             </a:extLst>
           </p:cNvPr>
@@ -9952,7 +9952,7 @@
           <p:cNvPr id="2" name="">
             <a:extLst xmlns:a="http://schemas.openxmlformats.org/drawingml/2006/main">
               <a:ext uri="{FF2B5EF4-FFF2-40B4-BE49-F238E27FC236}">
-                <a16:creationId xmlns:a16="http://schemas.microsoft.com/office/drawing/2014/main" id="{449F6979-3517-4C70-8B0C-396FE50A7423}"/>
+                <a16:creationId xmlns:a16="http://schemas.microsoft.com/office/drawing/2014/main" id="{88C5F03A-74A6-45D4-9B0E-0C959F6C0A98}"/>
               </a:ext>
             </a:extLst>
           </p:cNvPr>
@@ -10016,7 +10016,7 @@
           <p:cNvPr id="3" name="">
             <a:extLst xmlns:a="http://schemas.openxmlformats.org/drawingml/2006/main">
               <a:ext uri="{FF2B5EF4-FFF2-40B4-BE49-F238E27FC236}">
-                <a16:creationId xmlns:a16="http://schemas.microsoft.com/office/drawing/2014/main" id="{C4230ED1-6C65-469C-9AD4-7948BD4BF8B1}"/>
+                <a16:creationId xmlns:a16="http://schemas.microsoft.com/office/drawing/2014/main" id="{E19E6B9D-FAB5-469B-8BC4-05D4BEA6FA7A}"/>
               </a:ext>
             </a:extLst>
           </p:cNvPr>
@@ -10080,7 +10080,7 @@
           <p:cNvPr id="4" name="">
             <a:extLst xmlns:a="http://schemas.openxmlformats.org/drawingml/2006/main">
               <a:ext uri="{FF2B5EF4-FFF2-40B4-BE49-F238E27FC236}">
-                <a16:creationId xmlns:a16="http://schemas.microsoft.com/office/drawing/2014/main" id="{838222B8-E429-4911-93E4-A4E0F1678C19}"/>
+                <a16:creationId xmlns:a16="http://schemas.microsoft.com/office/drawing/2014/main" id="{394CAE82-AF82-4778-A5E2-C9DD8FC7BBD4}"/>
               </a:ext>
             </a:extLst>
           </p:cNvPr>
@@ -10116,13 +10116,13 @@
           <p:nvPr/>
         </p:nvPicPr>
         <p:blipFill>
-          <a:blip xmlns:r="http://schemas.openxmlformats.org/officeDocument/2006/relationships" xmlns:a="http://schemas.openxmlformats.org/drawingml/2006/main" r:embed="R2a01df70bed64147"/>
+          <a:blip xmlns:r="http://schemas.openxmlformats.org/officeDocument/2006/relationships" xmlns:a="http://schemas.openxmlformats.org/drawingml/2006/main" r:embed="R14c7c129221b4c44"/>
           <a:stretch xmlns:a="http://schemas.openxmlformats.org/drawingml/2006/main"/>
         </p:blipFill>
         <p:spPr>
           <a:xfrm xmlns:a="http://schemas.openxmlformats.org/drawingml/2006/main">
-            <a:off x="523875" y="1515105"/>
-            <a:ext cx="5143500" cy="3827790"/>
+            <a:off x="523875" y="1512121"/>
+            <a:ext cx="5143500" cy="3833757"/>
           </a:xfrm>
           <a:prstGeom xmlns:a="http://schemas.openxmlformats.org/drawingml/2006/main" prst="rect">
             <a:avLst/>
@@ -10138,13 +10138,13 @@
           <p:nvPr/>
         </p:nvPicPr>
         <p:blipFill>
-          <a:blip xmlns:r="http://schemas.openxmlformats.org/officeDocument/2006/relationships" xmlns:a="http://schemas.openxmlformats.org/drawingml/2006/main" r:embed="Rc526acfbccea417c"/>
+          <a:blip xmlns:r="http://schemas.openxmlformats.org/officeDocument/2006/relationships" xmlns:a="http://schemas.openxmlformats.org/drawingml/2006/main" r:embed="Rba4d5b2e8a804e21"/>
           <a:stretch xmlns:a="http://schemas.openxmlformats.org/drawingml/2006/main"/>
         </p:blipFill>
         <p:spPr>
           <a:xfrm xmlns:a="http://schemas.openxmlformats.org/drawingml/2006/main">
-            <a:off x="6191250" y="1574247"/>
-            <a:ext cx="4572000" cy="2852257"/>
+            <a:off x="6191250" y="1572848"/>
+            <a:ext cx="4572000" cy="2855053"/>
           </a:xfrm>
           <a:prstGeom xmlns:a="http://schemas.openxmlformats.org/drawingml/2006/main" prst="rect">
             <a:avLst/>
@@ -10156,7 +10156,7 @@
           <p:cNvPr id="7" name="">
             <a:extLst xmlns:a="http://schemas.openxmlformats.org/drawingml/2006/main">
               <a:ext uri="{FF2B5EF4-FFF2-40B4-BE49-F238E27FC236}">
-                <a16:creationId xmlns:a16="http://schemas.microsoft.com/office/drawing/2014/main" id="{4C0BDA16-BECA-4A6F-857B-FA2CF62AE0BA}"/>
+                <a16:creationId xmlns:a16="http://schemas.microsoft.com/office/drawing/2014/main" id="{BF11FF4F-60F9-488B-A3F3-A450BF12D636}"/>
               </a:ext>
             </a:extLst>
           </p:cNvPr>
@@ -10210,7 +10210,7 @@
                 <a:ea typeface="Microsoft YaHei"/>
                 <a:cs typeface="Microsoft YaHei"/>
               </a:rPr>
-              <a:t>综合流量、介数中心性、预测风险与历史延误率后，DEN、DFW、LAX、MCO、LAS 排名靠前。</a:t>
+              <a:t>综合流量、介数中心性、预测风险与历史延误率后，MIA、DEN、DFW、FLL、MCO 位于关键性前列。网络共 30 个节点、824 条有向航线。</a:t>
             </a:r>
           </a:p>
         </p:txBody>
@@ -10220,7 +10220,7 @@
           <p:cNvPr id="8" name="">
             <a:extLst xmlns:a="http://schemas.openxmlformats.org/drawingml/2006/main">
               <a:ext uri="{FF2B5EF4-FFF2-40B4-BE49-F238E27FC236}">
-                <a16:creationId xmlns:a16="http://schemas.microsoft.com/office/drawing/2014/main" id="{2467F1C9-735B-44D3-8E63-426F7E0D872F}"/>
+                <a16:creationId xmlns:a16="http://schemas.microsoft.com/office/drawing/2014/main" id="{C4AFEF7C-B76C-4C12-A181-6F1BE835D1CF}"/>
               </a:ext>
             </a:extLst>
           </p:cNvPr>
@@ -10284,7 +10284,7 @@
           <p:cNvPr id="9" name="">
             <a:extLst xmlns:a="http://schemas.openxmlformats.org/drawingml/2006/main">
               <a:ext uri="{FF2B5EF4-FFF2-40B4-BE49-F238E27FC236}">
-                <a16:creationId xmlns:a16="http://schemas.microsoft.com/office/drawing/2014/main" id="{0BB0C9DA-CD83-4D8E-87E5-8B608FEABF27}"/>
+                <a16:creationId xmlns:a16="http://schemas.microsoft.com/office/drawing/2014/main" id="{8BE334D6-B60A-40C3-8C2E-7DBF6424805A}"/>
               </a:ext>
             </a:extLst>
           </p:cNvPr>
@@ -10346,7 +10346,7 @@
     </p:spTree>
     <p:extLst>
       <p:ext uri="{BB962C8B-B14F-4D97-AF65-F5344CB8AC3E}">
-        <p14:creationId xmlns:p14="http://schemas.microsoft.com/office/powerpoint/2010/main" val="734020059"/>
+        <p14:creationId xmlns:p14="http://schemas.microsoft.com/office/powerpoint/2010/main" val="857232447"/>
       </p:ext>
     </p:extLst>
   </p:cSld>
@@ -10370,7 +10370,7 @@
           <p:cNvPr id="1" name="">
             <a:extLst xmlns:a="http://schemas.openxmlformats.org/drawingml/2006/main">
               <a:ext uri="{FF2B5EF4-FFF2-40B4-BE49-F238E27FC236}">
-                <a16:creationId xmlns:a16="http://schemas.microsoft.com/office/drawing/2014/main" id="{0D479C53-D0D1-411B-803D-8DE47449CE18}"/>
+                <a16:creationId xmlns:a16="http://schemas.microsoft.com/office/drawing/2014/main" id="{A8D5D324-2FCC-4ACC-929B-2779A73BFEFB}"/>
               </a:ext>
             </a:extLst>
           </p:cNvPr>
@@ -10402,7 +10402,7 @@
           <p:cNvPr id="2" name="">
             <a:extLst xmlns:a="http://schemas.openxmlformats.org/drawingml/2006/main">
               <a:ext uri="{FF2B5EF4-FFF2-40B4-BE49-F238E27FC236}">
-                <a16:creationId xmlns:a16="http://schemas.microsoft.com/office/drawing/2014/main" id="{BF04E7EC-DF8F-4D03-8E02-F51B973EDFDB}"/>
+                <a16:creationId xmlns:a16="http://schemas.microsoft.com/office/drawing/2014/main" id="{2E590934-C74F-4AE0-B476-F150932BD60E}"/>
               </a:ext>
             </a:extLst>
           </p:cNvPr>
@@ -10466,7 +10466,7 @@
           <p:cNvPr id="3" name="">
             <a:extLst xmlns:a="http://schemas.openxmlformats.org/drawingml/2006/main">
               <a:ext uri="{FF2B5EF4-FFF2-40B4-BE49-F238E27FC236}">
-                <a16:creationId xmlns:a16="http://schemas.microsoft.com/office/drawing/2014/main" id="{E0BE5103-1530-475D-A9EF-4173BE848E92}"/>
+                <a16:creationId xmlns:a16="http://schemas.microsoft.com/office/drawing/2014/main" id="{77AFBB9C-DA77-4D9D-830D-CB82D53E38A2}"/>
               </a:ext>
             </a:extLst>
           </p:cNvPr>
@@ -10530,7 +10530,7 @@
           <p:cNvPr id="4" name="">
             <a:extLst xmlns:a="http://schemas.openxmlformats.org/drawingml/2006/main">
               <a:ext uri="{FF2B5EF4-FFF2-40B4-BE49-F238E27FC236}">
-                <a16:creationId xmlns:a16="http://schemas.microsoft.com/office/drawing/2014/main" id="{2D9AE815-BE5F-4006-86AC-42F5C6DFDF8C}"/>
+                <a16:creationId xmlns:a16="http://schemas.microsoft.com/office/drawing/2014/main" id="{65D2BD4A-2964-4584-8D47-32FD16538C4B}"/>
               </a:ext>
             </a:extLst>
           </p:cNvPr>
@@ -10562,7 +10562,7 @@
           <p:cNvPr id="5" name="">
             <a:extLst xmlns:a="http://schemas.openxmlformats.org/drawingml/2006/main">
               <a:ext uri="{FF2B5EF4-FFF2-40B4-BE49-F238E27FC236}">
-                <a16:creationId xmlns:a16="http://schemas.microsoft.com/office/drawing/2014/main" id="{112BB92F-CFF5-4E66-B821-FE95555E19B4}"/>
+                <a16:creationId xmlns:a16="http://schemas.microsoft.com/office/drawing/2014/main" id="{9CDE060E-186C-4F30-9940-C87835949125}"/>
               </a:ext>
             </a:extLst>
           </p:cNvPr>
@@ -10594,7 +10594,7 @@
           <p:cNvPr id="6" name="">
             <a:extLst xmlns:a="http://schemas.openxmlformats.org/drawingml/2006/main">
               <a:ext uri="{FF2B5EF4-FFF2-40B4-BE49-F238E27FC236}">
-                <a16:creationId xmlns:a16="http://schemas.microsoft.com/office/drawing/2014/main" id="{BCC2B43D-6D65-42F1-9A64-53E7DBC6B8AC}"/>
+                <a16:creationId xmlns:a16="http://schemas.microsoft.com/office/drawing/2014/main" id="{33C7FE30-C446-43D9-8F40-1575E82CF5DB}"/>
               </a:ext>
             </a:extLst>
           </p:cNvPr>
@@ -10658,7 +10658,7 @@
           <p:cNvPr id="7" name="">
             <a:extLst xmlns:a="http://schemas.openxmlformats.org/drawingml/2006/main">
               <a:ext uri="{FF2B5EF4-FFF2-40B4-BE49-F238E27FC236}">
-                <a16:creationId xmlns:a16="http://schemas.microsoft.com/office/drawing/2014/main" id="{513D5A4D-EA5F-460D-B110-CC368354276D}"/>
+                <a16:creationId xmlns:a16="http://schemas.microsoft.com/office/drawing/2014/main" id="{41004671-DCB7-403B-BAAF-C053C5371841}"/>
               </a:ext>
             </a:extLst>
           </p:cNvPr>
@@ -10712,7 +10712,7 @@
                 <a:ea typeface="Microsoft YaHei"/>
                 <a:cs typeface="Microsoft YaHei"/>
               </a:rPr>
-              <a:t>谱半径 0.820；单步 MAE 11.63 分钟</a:t>
+              <a:t>谱半径 0.920；单步 MAE 9.74 分钟</a:t>
             </a:r>
           </a:p>
         </p:txBody>
@@ -10726,13 +10726,13 @@
           <p:nvPr/>
         </p:nvPicPr>
         <p:blipFill>
-          <a:blip xmlns:r="http://schemas.openxmlformats.org/officeDocument/2006/relationships" xmlns:a="http://schemas.openxmlformats.org/drawingml/2006/main" r:embed="R6f82a529c4f84c45"/>
+          <a:blip xmlns:r="http://schemas.openxmlformats.org/officeDocument/2006/relationships" xmlns:a="http://schemas.openxmlformats.org/drawingml/2006/main" r:embed="Readba00d959b4c35"/>
           <a:stretch xmlns:a="http://schemas.openxmlformats.org/drawingml/2006/main"/>
         </p:blipFill>
         <p:spPr>
           <a:xfrm xmlns:a="http://schemas.openxmlformats.org/drawingml/2006/main">
-            <a:off x="5429250" y="1613447"/>
-            <a:ext cx="3048000" cy="2678607"/>
+            <a:off x="5429250" y="1612316"/>
+            <a:ext cx="3048000" cy="2680868"/>
           </a:xfrm>
           <a:prstGeom xmlns:a="http://schemas.openxmlformats.org/drawingml/2006/main" prst="rect">
             <a:avLst/>
@@ -10748,13 +10748,13 @@
           <p:nvPr/>
         </p:nvPicPr>
         <p:blipFill>
-          <a:blip xmlns:r="http://schemas.openxmlformats.org/officeDocument/2006/relationships" xmlns:a="http://schemas.openxmlformats.org/drawingml/2006/main" r:embed="R071686a0bf8e4a56"/>
+          <a:blip xmlns:r="http://schemas.openxmlformats.org/officeDocument/2006/relationships" xmlns:a="http://schemas.openxmlformats.org/drawingml/2006/main" r:embed="R789c54b9d8c447a6"/>
           <a:stretch xmlns:a="http://schemas.openxmlformats.org/drawingml/2006/main"/>
         </p:blipFill>
         <p:spPr>
           <a:xfrm xmlns:a="http://schemas.openxmlformats.org/drawingml/2006/main">
-            <a:off x="8334375" y="2067083"/>
-            <a:ext cx="3143250" cy="1771334"/>
+            <a:off x="8334375" y="2066215"/>
+            <a:ext cx="3143250" cy="1773071"/>
           </a:xfrm>
           <a:prstGeom xmlns:a="http://schemas.openxmlformats.org/drawingml/2006/main" prst="rect">
             <a:avLst/>
@@ -10766,7 +10766,7 @@
           <p:cNvPr id="10" name="">
             <a:extLst xmlns:a="http://schemas.openxmlformats.org/drawingml/2006/main">
               <a:ext uri="{FF2B5EF4-FFF2-40B4-BE49-F238E27FC236}">
-                <a16:creationId xmlns:a16="http://schemas.microsoft.com/office/drawing/2014/main" id="{313A28EC-7A93-44A6-8FB8-4164ED624759}"/>
+                <a16:creationId xmlns:a16="http://schemas.microsoft.com/office/drawing/2014/main" id="{23E7CF4A-9EAC-464B-9AE8-A98027DB2C19}"/>
               </a:ext>
             </a:extLst>
           </p:cNvPr>
@@ -10830,7 +10830,7 @@
           <p:cNvPr id="11" name="">
             <a:extLst xmlns:a="http://schemas.openxmlformats.org/drawingml/2006/main">
               <a:ext uri="{FF2B5EF4-FFF2-40B4-BE49-F238E27FC236}">
-                <a16:creationId xmlns:a16="http://schemas.microsoft.com/office/drawing/2014/main" id="{0582C955-940B-4035-81B5-3D722A193F1E}"/>
+                <a16:creationId xmlns:a16="http://schemas.microsoft.com/office/drawing/2014/main" id="{B027C2A2-4D43-44D8-8DB7-2036E0EDA81A}"/>
               </a:ext>
             </a:extLst>
           </p:cNvPr>
@@ -10894,7 +10894,7 @@
           <p:cNvPr id="12" name="">
             <a:extLst xmlns:a="http://schemas.openxmlformats.org/drawingml/2006/main">
               <a:ext uri="{FF2B5EF4-FFF2-40B4-BE49-F238E27FC236}">
-                <a16:creationId xmlns:a16="http://schemas.microsoft.com/office/drawing/2014/main" id="{597F8F9A-26AD-4DAD-ACAA-4E126862925B}"/>
+                <a16:creationId xmlns:a16="http://schemas.microsoft.com/office/drawing/2014/main" id="{AFBA440A-7066-4005-B816-50E8ED72778D}"/>
               </a:ext>
             </a:extLst>
           </p:cNvPr>
@@ -10956,7 +10956,7 @@
     </p:spTree>
     <p:extLst>
       <p:ext uri="{BB962C8B-B14F-4D97-AF65-F5344CB8AC3E}">
-        <p14:creationId xmlns:p14="http://schemas.microsoft.com/office/powerpoint/2010/main" val="1791337345"/>
+        <p14:creationId xmlns:p14="http://schemas.microsoft.com/office/powerpoint/2010/main" val="1794224159"/>
       </p:ext>
     </p:extLst>
   </p:cSld>

</xml_diff>